<commit_message>
W01 D2 afternoon deck carries the morning's new depth
Both orders of the mix and rate split, the Business median and middle
half behind the rupee lens, the retention-cost estimates in the reply to
Marketing, the season as a rival hypothesis with the data that settles
it, how a failure log is written, and deeper model answers in the drill.

Co-Authored-By: Claude Opus 5.5 <noreply@anthropic.com>
Claude-Session: https://claude.ai/code/session_011NVg1vHjDBgHjSC8kYZMtZ
</commit_message>
<xml_diff>
--- a/content/W01/D2/slides/C2_W01_D02_half2_STUDENT.pptx
+++ b/content/W01/D2/slides/C2_W01_D02_half2_STUDENT.pptx
@@ -625,7 +625,17 @@
           </a:p>
           <a:p>
             <a:r>
-              <a:t>average order to grow. Interview question 7 is this slide.</a:t>
+              <a:t>average order to grow. Move the rates first instead, at Q1's shares, and the rates explain Rs 9,203</a:t>
+            </a:r>
+          </a:p>
+          <a:p>
+            <a:r>
+              <a:t>and the mix Rs 24,028, 72 percent: the split moves by three points and the answer does not. Say the</a:t>
+            </a:r>
+          </a:p>
+          <a:p>
+            <a:r>
+              <a:t>order you used, as in the morning's bridge. Interview question 7 is this slide.</a:t>
             </a:r>
           </a:p>
         </p:txBody>
@@ -1175,7 +1185,22 @@
           </a:p>
           <a:p>
             <a:r>
-              <a:t>when the rupees are smaller. Interview question 11 is this slide.</a:t>
+              <a:t>when the rupees are smaller. The cost argument comes from the morning's S3: HBR (Gallo, 2014)</a:t>
+            </a:r>
+          </a:p>
+          <a:p>
+            <a:r>
+              <a:t>summarises studies putting acquisition at 5 to 25 times the cost of retention; those are estimates</a:t>
+            </a:r>
+          </a:p>
+          <a:p>
+            <a:r>
+              <a:t>across industries, not Kalpa's figures, so pairs say "estimates" when they use them. The frequency</a:t>
+            </a:r>
+          </a:p>
+          <a:p>
+            <a:r>
+              <a:t>lever works on the 22 members Kalpa already has. Interview question 11 is this slide.</a:t>
             </a:r>
           </a:p>
         </p:txBody>
@@ -1260,12 +1285,27 @@
           </a:p>
           <a:p>
             <a:r>
-              <a:t>is Thursday's kind of question. Hold questions about any single month for Wednesday, when the</a:t>
-            </a:r>
-          </a:p>
-          <a:p>
-            <a:r>
-              <a:t>export is profiled row by row.</a:t>
+              <a:t>is Thursday's kind of question. The rival explanation a sharp pair raises is the season: July opens</a:t>
+            </a:r>
+          </a:p>
+          <a:p>
+            <a:r>
+              <a:t>the monsoon quarter, and a seasonal dip would also start in July. Retail-Core, flat through the same</a:t>
+            </a:r>
+          </a:p>
+          <a:p>
+            <a:r>
+              <a:t>months, is evidence against a season that hits everyone; a season that hits members harder is still</a:t>
+            </a:r>
+          </a:p>
+          <a:p>
+            <a:r>
+              <a:t>possible, and last year's Q2 by segment settles it. Hold questions about any single month for</a:t>
+            </a:r>
+          </a:p>
+          <a:p>
+            <a:r>
+              <a:t>Wednesday, when the export is profiled row by row.</a:t>
             </a:r>
           </a:p>
         </p:txBody>
@@ -1500,12 +1540,27 @@
           </a:p>
           <a:p>
             <a:r>
-              <a:t>for pairs who say "the evidence would be". Only the second earns Meera's trust. Interview question</a:t>
-            </a:r>
-          </a:p>
-          <a:p>
-            <a:r>
-              <a:t>12 is this slide.</a:t>
+              <a:t>for pairs who say "the evidence would be". Only the second earns Meera's trust. One systems point on</a:t>
+            </a:r>
+          </a:p>
+          <a:p>
+            <a:r>
+              <a:t>the reorder logs: ask how they are written before trusting them. A failure log that records only the</a:t>
+            </a:r>
+          </a:p>
+          <a:p>
+            <a:r>
+              <a:t>attempts that reached the server misses every member whose tap never got that far, and that absence</a:t>
+            </a:r>
+          </a:p>
+          <a:p>
+            <a:r>
+              <a:t>is not random, which is the morning's missing-field lesson in a new place. Interview question 12 is</a:t>
+            </a:r>
+          </a:p>
+          <a:p>
+            <a:r>
+              <a:t>this slide.</a:t>
             </a:r>
           </a:p>
         </p:txBody>
@@ -1700,7 +1755,12 @@
           </a:p>
           <a:p>
             <a:r>
-              <a:t>closed quarters, or the same weeks of each.</a:t>
+              <a:t>closed quarters, or the same weeks of each; and name the season, which only the same quarter last</a:t>
+            </a:r>
+          </a:p>
+          <a:p>
+            <a:r>
+              <a:t>year removes, the reason retailers keep a 4-5-4 calendar.</a:t>
             </a:r>
           </a:p>
         </p:txBody>
@@ -1780,7 +1840,17 @@
           </a:p>
           <a:p>
             <a:r>
-              <a:t>what evidence would change your mind, and propose a check before the spend rather than a refusal.</a:t>
+              <a:t>what evidence would change your mind, and propose a check before the spend rather than a refusal;</a:t>
+            </a:r>
+          </a:p>
+          <a:p>
+            <a:r>
+              <a:t>the frequency lever works on customers already won, which published estimates put at a fraction of</a:t>
+            </a:r>
+          </a:p>
+          <a:p>
+            <a:r>
+              <a:t>the cost of acquiring new ones.</a:t>
             </a:r>
           </a:p>
           <a:p>
@@ -1790,7 +1860,17 @@
           </a:p>
           <a:p>
             <a:r>
-              <a:t>order value, then order value on the new orders, and check the moves sum to the change.</a:t>
+              <a:t>order value, then order value on the new orders, and check the moves sum to the change. Say which</a:t>
+            </a:r>
+          </a:p>
+          <a:p>
+            <a:r>
+              <a:t>branch moved first, because moving order value first charges frequency Rs 60.9 lakh instead of</a:t>
+            </a:r>
+          </a:p>
+          <a:p>
+            <a:r>
+              <a:t>Rs 51.6 lakh, or use the symmetric logarithmic split, which gives Rs 55.9 lakh whatever the order.</a:t>
             </a:r>
           </a:p>
           <a:p>
@@ -1810,7 +1890,12 @@
           </a:p>
           <a:p>
             <a:r>
-              <a:t>default and why, and bound how much it could matter.</a:t>
+              <a:t>default and why, and bound how much it could matter. Ask which system left it empty, because absence</a:t>
+            </a:r>
+          </a:p>
+          <a:p>
+            <a:r>
+              <a:t>is rarely random, and whichever of in, try/except or get you use, it encodes that decision.</a:t>
             </a:r>
           </a:p>
         </p:txBody>
@@ -1895,7 +1980,12 @@
           </a:p>
           <a:p>
             <a:r>
-              <a:t>thirty-four.</a:t>
+              <a:t>thirty-four. A ratio of totals, never a mean of ratios: reports that store averages and average</a:t>
+            </a:r>
+          </a:p>
+          <a:p>
+            <a:r>
+              <a:t>them again make the same mistake at every level.</a:t>
             </a:r>
           </a:p>
           <a:p>
@@ -2535,12 +2625,17 @@
           </a:p>
           <a:p>
             <a:r>
-              <a:t>other way: a blend moves when its weights move, even if no part of it changed. Then release the</a:t>
-            </a:r>
-          </a:p>
-          <a:p>
-            <a:r>
-              <a:t>room to the notebook for 50 minutes.</a:t>
+              <a:t>other way: a blend moves when its weights move, even if no part of it changed. The morning showed</a:t>
+            </a:r>
+          </a:p>
+          <a:p>
+            <a:r>
+              <a:t>that a bridge's split depends on which branch moves first; the same holds here, and the debrief puts</a:t>
+            </a:r>
+          </a:p>
+          <a:p>
+            <a:r>
+              <a:t>both orders side by side. Then release the room to the notebook for 50 minutes.</a:t>
             </a:r>
           </a:p>
         </p:txBody>
@@ -2706,6 +2801,26 @@
           <a:p>
             <a:r>
               <a:t>picking one lens and calling it the story. Consumer segments fell from Rs 2,28,820 to Rs 1,58,540.</a:t>
+            </a:r>
+          </a:p>
+          <a:p>
+            <a:r>
+              <a:t>Tie it to the morning's describe: the Business median held, the middle half of its orders widened</a:t>
+            </a:r>
+          </a:p>
+          <a:p>
+            <a:r>
+              <a:t>only 13 percent, and one order of Rs 29,45,460 stretched the range. Twenty orders a quarter, each</a:t>
+            </a:r>
+          </a:p>
+          <a:p>
+            <a:r>
+              <a:t>worth lakhs, is lumpy revenue: three orders landing a week later would move this lens by lakhs, which</a:t>
+            </a:r>
+          </a:p>
+          <a:p>
+            <a:r>
+              <a:t>is why it gets checked before anyone acts, and why Thursday asks what chance alone can produce.</a:t>
             </a:r>
           </a:p>
         </p:txBody>
@@ -7455,7 +7570,7 @@
                 </a:solidFill>
                 <a:latin typeface="Calibri"/>
               </a:rPr>
-              <a:t>FROM MIX</a:t>
+              <a:t>FROM MIX, MOVED FIRST</a:t>
             </a:r>
           </a:p>
         </p:txBody>
@@ -7490,7 +7605,7 @@
                 </a:solidFill>
                 <a:latin typeface="Calibri"/>
               </a:rPr>
-              <a:t>about 69 percent</a:t>
+              <a:t>69 percent; 72 if moved second</a:t>
             </a:r>
           </a:p>
         </p:txBody>
@@ -7639,7 +7754,7 @@
                 </a:solidFill>
                 <a:latin typeface="Calibri"/>
               </a:rPr>
-              <a:t>inside segments</a:t>
+              <a:t>Rs 9,203 if moved first</a:t>
             </a:r>
           </a:p>
         </p:txBody>
@@ -14406,7 +14521,7 @@
         <p:spPr>
           <a:xfrm>
             <a:off x="530352" y="3419856"/>
-            <a:ext cx="11130991" cy="807720"/>
+            <a:ext cx="11130991" cy="1074420"/>
           </a:xfrm>
           <a:prstGeom prst="roundRect">
             <a:avLst>
@@ -14454,7 +14569,7 @@
         <p:spPr>
           <a:xfrm>
             <a:off x="676656" y="3547872"/>
-            <a:ext cx="45720" cy="551688"/>
+            <a:ext cx="45720" cy="818388"/>
           </a:xfrm>
           <a:prstGeom prst="roundRect">
             <a:avLst>
@@ -14500,7 +14615,7 @@
         <p:spPr>
           <a:xfrm>
             <a:off x="877824" y="3538728"/>
-            <a:ext cx="10564063" cy="624840"/>
+            <a:ext cx="10564063" cy="891540"/>
           </a:xfrm>
           <a:prstGeom prst="rect">
             <a:avLst/>
@@ -14529,7 +14644,7 @@
                 </a:solidFill>
                 <a:latin typeface="Calibri"/>
               </a:rPr>
-              <a:t>The rupee fall in Business rests on three orders; the Retail-Plus fall rests on every member of a paid tier buying half as often.</a:t>
+              <a:t>The rupee fall in Business rests on three orders; the Retail-Plus fall rests on every member of a paid tier buying half as often. Members already won are the cheaper lever: published estimates put acquiring a customer at 5 to 25 times the cost of keeping one.</a:t>
             </a:r>
           </a:p>
         </p:txBody>
@@ -15221,8 +15336,8 @@
         </p:blipFill>
         <p:spPr>
           <a:xfrm>
-            <a:off x="2286863" y="1664208"/>
-            <a:ext cx="7617968" cy="3808984"/>
+            <a:off x="2563215" y="1664208"/>
+            <a:ext cx="7065264" cy="3532632"/>
           </a:xfrm>
           <a:prstGeom prst="rect">
             <a:avLst/>
@@ -15237,8 +15352,8 @@
         </p:nvSpPr>
         <p:spPr>
           <a:xfrm>
-            <a:off x="530352" y="5518912"/>
-            <a:ext cx="11130991" cy="680720"/>
+            <a:off x="530352" y="5242560"/>
+            <a:ext cx="11130991" cy="957072"/>
           </a:xfrm>
           <a:prstGeom prst="rect">
             <a:avLst/>
@@ -15258,7 +15373,7 @@
                 </a:solidFill>
                 <a:latin typeface="Calibri"/>
               </a:rPr>
-              <a:t>Retail-Plus placed 18 orders from 1 July to 24 August and 8 from 25 August to 30 September. Retail-Core, the comparison segment, stayed flat.</a:t>
+              <a:t>Retail-Plus placed 18 orders from 1 July to 24 August and 8 from 25 August to 30 September. Retail-Core, the comparison segment, stayed flat, which argues against a season that hit every customer, though only last year's Q2 can rule the season out for the tier.</a:t>
             </a:r>
           </a:p>
         </p:txBody>
@@ -17598,7 +17713,7 @@
                 </a:solidFill>
                 <a:latin typeface="Georgia"/>
               </a:rPr>
-              <a:t>Two hypotheses, and the data that settles each</a:t>
+              <a:t>Two hypotheses, a rival, and the data for each</a:t>
             </a:r>
           </a:p>
         </p:txBody>
@@ -17633,7 +17748,7 @@
                 </a:solidFill>
                 <a:latin typeface="Calibri"/>
               </a:rPr>
-              <a:t>Neither can be settled from this file, so the answer names the data to ask for.</a:t>
+              <a:t>None can be settled from this file, so the answer names the data to ask for.</a:t>
             </a:r>
           </a:p>
         </p:txBody>
@@ -17647,7 +17762,7 @@
         <p:spPr>
           <a:xfrm>
             <a:off x="530352" y="1956816"/>
-            <a:ext cx="5474055" cy="2154428"/>
+            <a:ext cx="3588410" cy="2385568"/>
           </a:xfrm>
           <a:prstGeom prst="roundRect">
             <a:avLst>
@@ -17769,7 +17884,7 @@
         <p:spPr>
           <a:xfrm>
             <a:off x="731519" y="2724912"/>
-            <a:ext cx="5071719" cy="160401"/>
+            <a:ext cx="3186074" cy="160401"/>
           </a:xfrm>
           <a:prstGeom prst="rect">
             <a:avLst/>
@@ -17804,7 +17919,7 @@
         <p:spPr>
           <a:xfrm>
             <a:off x="731519" y="2962656"/>
-            <a:ext cx="5071719" cy="267716"/>
+            <a:ext cx="3186074" cy="267716"/>
           </a:xfrm>
           <a:prstGeom prst="rect">
             <a:avLst/>
@@ -17839,7 +17954,7 @@
         <p:spPr>
           <a:xfrm>
             <a:off x="731519" y="3303524"/>
-            <a:ext cx="5071719" cy="581406"/>
+            <a:ext cx="3186074" cy="763016"/>
           </a:xfrm>
           <a:prstGeom prst="rect">
             <a:avLst/>
@@ -17873,8 +17988,8 @@
         </p:nvSpPr>
         <p:spPr>
           <a:xfrm>
-            <a:off x="6187287" y="1956816"/>
-            <a:ext cx="5474055" cy="2154428"/>
+            <a:off x="4301642" y="1956816"/>
+            <a:ext cx="3588410" cy="2385568"/>
           </a:xfrm>
           <a:prstGeom prst="roundRect">
             <a:avLst>
@@ -17933,7 +18048,7 @@
         </p:nvSpPr>
         <p:spPr>
           <a:xfrm>
-            <a:off x="6388455" y="2157984"/>
+            <a:off x="4502810" y="2157984"/>
             <a:ext cx="457200" cy="457200"/>
           </a:xfrm>
           <a:prstGeom prst="ellipse">
@@ -17985,7 +18100,7 @@
         </p:blipFill>
         <p:spPr>
           <a:xfrm>
-            <a:off x="6498183" y="2267712"/>
+            <a:off x="4612538" y="2267712"/>
             <a:ext cx="237744" cy="237744"/>
           </a:xfrm>
           <a:prstGeom prst="rect">
@@ -18001,8 +18116,8 @@
         </p:nvSpPr>
         <p:spPr>
           <a:xfrm>
-            <a:off x="6388455" y="2724912"/>
-            <a:ext cx="5071719" cy="160401"/>
+            <a:off x="4502810" y="2724912"/>
+            <a:ext cx="3186074" cy="160401"/>
           </a:xfrm>
           <a:prstGeom prst="rect">
             <a:avLst/>
@@ -18036,8 +18151,8 @@
         </p:nvSpPr>
         <p:spPr>
           <a:xfrm>
-            <a:off x="6388455" y="2962656"/>
-            <a:ext cx="5071719" cy="267716"/>
+            <a:off x="4502810" y="2962656"/>
+            <a:ext cx="3186074" cy="498856"/>
           </a:xfrm>
           <a:prstGeom prst="rect">
             <a:avLst/>
@@ -18071,8 +18186,8 @@
         </p:nvSpPr>
         <p:spPr>
           <a:xfrm>
-            <a:off x="6388455" y="3303524"/>
-            <a:ext cx="5071719" cy="399796"/>
+            <a:off x="4502810" y="3534664"/>
+            <a:ext cx="3186074" cy="581406"/>
           </a:xfrm>
           <a:prstGeom prst="rect">
             <a:avLst/>
@@ -18106,7 +18221,234 @@
         </p:nvSpPr>
         <p:spPr>
           <a:xfrm>
-            <a:off x="530352" y="4294124"/>
+            <a:off x="8072932" y="1956816"/>
+            <a:ext cx="3588410" cy="2385568"/>
+          </a:xfrm>
+          <a:prstGeom prst="roundRect">
+            <a:avLst>
+              <a:gd name="adj" fmla="val 5000"/>
+            </a:avLst>
+          </a:prstGeom>
+          <a:solidFill>
+            <a:srgbClr val="FFFFFF"/>
+          </a:solidFill>
+          <a:ln w="9525">
+            <a:solidFill>
+              <a:srgbClr val="E4E1F1"/>
+            </a:solidFill>
+          </a:ln>
+          <a:effectLst>
+            <a:outerShdw blurRad="76200" dist="19050" dir="5400000" algn="bl" rotWithShape="0">
+              <a:srgbClr val="1A0F5C">
+                <a:alpha val="12000"/>
+              </a:srgbClr>
+            </a:outerShdw>
+          </a:effectLst>
+        </p:spPr>
+        <p:style>
+          <a:lnRef idx="1">
+            <a:schemeClr val="accent1"/>
+          </a:lnRef>
+          <a:fillRef idx="3">
+            <a:schemeClr val="accent1"/>
+          </a:fillRef>
+          <a:effectRef idx="2">
+            <a:schemeClr val="accent1"/>
+          </a:effectRef>
+          <a:fontRef idx="minor">
+            <a:schemeClr val="lt1"/>
+          </a:fontRef>
+        </p:style>
+        <p:txBody>
+          <a:bodyPr rtlCol="0" anchor="ctr" wrap="square"/>
+          <a:lstStyle/>
+          <a:p>
+            <a:pPr algn="ctr"/>
+          </a:p>
+        </p:txBody>
+      </p:sp>
+      <p:sp>
+        <p:nvSpPr>
+          <p:cNvPr id="22" name="Oval 21"/>
+          <p:cNvSpPr/>
+          <p:nvPr/>
+        </p:nvSpPr>
+        <p:spPr>
+          <a:xfrm>
+            <a:off x="8274100" y="2157984"/>
+            <a:ext cx="457200" cy="457200"/>
+          </a:xfrm>
+          <a:prstGeom prst="ellipse">
+            <a:avLst/>
+          </a:prstGeom>
+          <a:solidFill>
+            <a:srgbClr val="EEEAFB"/>
+          </a:solidFill>
+          <a:ln>
+            <a:noFill/>
+          </a:ln>
+          <a:effectLst/>
+        </p:spPr>
+        <p:style>
+          <a:lnRef idx="1">
+            <a:schemeClr val="accent1"/>
+          </a:lnRef>
+          <a:fillRef idx="3">
+            <a:schemeClr val="accent1"/>
+          </a:fillRef>
+          <a:effectRef idx="2">
+            <a:schemeClr val="accent1"/>
+          </a:effectRef>
+          <a:fontRef idx="minor">
+            <a:schemeClr val="lt1"/>
+          </a:fontRef>
+        </p:style>
+        <p:txBody>
+          <a:bodyPr rtlCol="0" anchor="ctr" wrap="square"/>
+          <a:lstStyle/>
+          <a:p>
+            <a:pPr algn="ctr"/>
+          </a:p>
+        </p:txBody>
+      </p:sp>
+      <p:pic>
+        <p:nvPicPr>
+          <p:cNvPr id="23" name="Picture 22" descr="cloud-rain_994c880de426.png"/>
+          <p:cNvPicPr>
+            <a:picLocks noChangeAspect="1"/>
+          </p:cNvPicPr>
+          <p:nvPr/>
+        </p:nvPicPr>
+        <p:blipFill>
+          <a:blip r:embed="rId6"/>
+          <a:stretch>
+            <a:fillRect/>
+          </a:stretch>
+        </p:blipFill>
+        <p:spPr>
+          <a:xfrm>
+            <a:off x="8383828" y="2267712"/>
+            <a:ext cx="237744" cy="237744"/>
+          </a:xfrm>
+          <a:prstGeom prst="rect">
+            <a:avLst/>
+          </a:prstGeom>
+        </p:spPr>
+      </p:pic>
+      <p:sp>
+        <p:nvSpPr>
+          <p:cNvPr id="24" name="TextBox 23"/>
+          <p:cNvSpPr txBox="1"/>
+          <p:nvPr/>
+        </p:nvSpPr>
+        <p:spPr>
+          <a:xfrm>
+            <a:off x="8274100" y="2724912"/>
+            <a:ext cx="3186074" cy="160401"/>
+          </a:xfrm>
+          <a:prstGeom prst="rect">
+            <a:avLst/>
+          </a:prstGeom>
+          <a:noFill/>
+        </p:spPr>
+        <p:txBody>
+          <a:bodyPr wrap="square" anchor="t" lIns="0" rIns="0" tIns="0" bIns="0">
+            <a:spAutoFit/>
+          </a:bodyPr>
+          <a:lstStyle/>
+          <a:p>
+            <a:pPr algn="l"/>
+            <a:r>
+              <a:rPr sz="750" b="1" i="0" spc="250">
+                <a:solidFill>
+                  <a:srgbClr val="5B3FD6"/>
+                </a:solidFill>
+                <a:latin typeface="Calibri"/>
+              </a:rPr>
+              <a:t>THE RIVAL</a:t>
+            </a:r>
+          </a:p>
+        </p:txBody>
+      </p:sp>
+      <p:sp>
+        <p:nvSpPr>
+          <p:cNvPr id="25" name="TextBox 24"/>
+          <p:cNvSpPr txBox="1"/>
+          <p:nvPr/>
+        </p:nvSpPr>
+        <p:spPr>
+          <a:xfrm>
+            <a:off x="8274100" y="2962656"/>
+            <a:ext cx="3186074" cy="267716"/>
+          </a:xfrm>
+          <a:prstGeom prst="rect">
+            <a:avLst/>
+          </a:prstGeom>
+          <a:noFill/>
+        </p:spPr>
+        <p:txBody>
+          <a:bodyPr wrap="square" anchor="t" lIns="0" rIns="0" tIns="0" bIns="0">
+            <a:spAutoFit/>
+          </a:bodyPr>
+          <a:lstStyle/>
+          <a:p>
+            <a:pPr algn="l"/>
+            <a:r>
+              <a:rPr sz="1400" b="1" i="0">
+                <a:solidFill>
+                  <a:srgbClr val="1A0F5C"/>
+                </a:solidFill>
+                <a:latin typeface="Calibri"/>
+              </a:rPr>
+              <a:t>The season</a:t>
+            </a:r>
+          </a:p>
+        </p:txBody>
+      </p:sp>
+      <p:sp>
+        <p:nvSpPr>
+          <p:cNvPr id="26" name="TextBox 25"/>
+          <p:cNvSpPr txBox="1"/>
+          <p:nvPr/>
+        </p:nvSpPr>
+        <p:spPr>
+          <a:xfrm>
+            <a:off x="8274100" y="3303524"/>
+            <a:ext cx="3186074" cy="581406"/>
+          </a:xfrm>
+          <a:prstGeom prst="rect">
+            <a:avLst/>
+          </a:prstGeom>
+          <a:noFill/>
+        </p:spPr>
+        <p:txBody>
+          <a:bodyPr wrap="square" anchor="t" lIns="0" rIns="0" tIns="0" bIns="0">
+            <a:spAutoFit/>
+          </a:bodyPr>
+          <a:lstStyle/>
+          <a:p>
+            <a:pPr algn="l"/>
+            <a:r>
+              <a:rPr sz="1100" b="0" i="0">
+                <a:solidFill>
+                  <a:srgbClr val="6B6690"/>
+                </a:solidFill>
+                <a:latin typeface="Calibri"/>
+              </a:rPr>
+              <a:t>A monsoon dip that hit members harder. Settled by last year's Q2 for Retail-Plus against Retail-Core.</a:t>
+            </a:r>
+          </a:p>
+        </p:txBody>
+      </p:sp>
+      <p:sp>
+        <p:nvSpPr>
+          <p:cNvPr id="27" name="Rounded Rectangle 26"/>
+          <p:cNvSpPr/>
+          <p:nvPr/>
+        </p:nvSpPr>
+        <p:spPr>
+          <a:xfrm>
+            <a:off x="530352" y="4525264"/>
             <a:ext cx="11130991" cy="1121664"/>
           </a:xfrm>
           <a:prstGeom prst="roundRect">
@@ -18154,13 +18496,13 @@
       </p:sp>
       <p:sp>
         <p:nvSpPr>
-          <p:cNvPr id="22" name="Oval 21"/>
+          <p:cNvPr id="28" name="Oval 27"/>
           <p:cNvSpPr/>
           <p:nvPr/>
         </p:nvSpPr>
         <p:spPr>
           <a:xfrm>
-            <a:off x="758952" y="4626356"/>
+            <a:off x="758952" y="4857496"/>
             <a:ext cx="457200" cy="457200"/>
           </a:xfrm>
           <a:prstGeom prst="ellipse">
@@ -18198,21 +18540,21 @@
       </p:sp>
       <p:pic>
         <p:nvPicPr>
-          <p:cNvPr id="23" name="Picture 22" descr="search-check_6571e64a041f.png"/>
+          <p:cNvPr id="29" name="Picture 28" descr="search-check_6571e64a041f.png"/>
           <p:cNvPicPr>
             <a:picLocks noChangeAspect="1"/>
           </p:cNvPicPr>
           <p:nvPr/>
         </p:nvPicPr>
         <p:blipFill>
-          <a:blip r:embed="rId6"/>
+          <a:blip r:embed="rId7"/>
           <a:stretch>
             <a:fillRect/>
           </a:stretch>
         </p:blipFill>
         <p:spPr>
           <a:xfrm>
-            <a:off x="868680" y="4736084"/>
+            <a:off x="868680" y="4967224"/>
             <a:ext cx="237744" cy="237744"/>
           </a:xfrm>
           <a:prstGeom prst="rect">
@@ -18222,13 +18564,13 @@
       </p:pic>
       <p:sp>
         <p:nvSpPr>
-          <p:cNvPr id="24" name="TextBox 23"/>
-          <p:cNvSpPr txBox="1"/>
-          <p:nvPr/>
-        </p:nvSpPr>
-        <p:spPr>
-          <a:xfrm>
-            <a:off x="1399031" y="4440428"/>
+          <p:cNvPr id="30" name="TextBox 29"/>
+          <p:cNvSpPr txBox="1"/>
+          <p:nvPr/>
+        </p:nvSpPr>
+        <p:spPr>
+          <a:xfrm>
+            <a:off x="1399031" y="4671568"/>
             <a:ext cx="9987991" cy="160401"/>
           </a:xfrm>
           <a:prstGeom prst="rect">
@@ -18257,13 +18599,13 @@
       </p:sp>
       <p:sp>
         <p:nvSpPr>
-          <p:cNvPr id="25" name="TextBox 24"/>
-          <p:cNvSpPr txBox="1"/>
-          <p:nvPr/>
-        </p:nvSpPr>
-        <p:spPr>
-          <a:xfrm>
-            <a:off x="1399031" y="4659884"/>
+          <p:cNvPr id="31" name="TextBox 30"/>
+          <p:cNvSpPr txBox="1"/>
+          <p:nvPr/>
+        </p:nvSpPr>
+        <p:spPr>
+          <a:xfrm>
+            <a:off x="1399031" y="4891024"/>
             <a:ext cx="9987991" cy="682752"/>
           </a:xfrm>
           <a:prstGeom prst="rect">
@@ -18291,7 +18633,7 @@
       </p:sp>
       <p:sp>
         <p:nvSpPr>
-          <p:cNvPr id="26" name="Oval 25"/>
+          <p:cNvPr id="32" name="Oval 31"/>
           <p:cNvSpPr/>
           <p:nvPr/>
         </p:nvSpPr>
@@ -18335,7 +18677,7 @@
       </p:sp>
       <p:sp>
         <p:nvSpPr>
-          <p:cNvPr id="27" name="TextBox 26"/>
+          <p:cNvPr id="33" name="TextBox 32"/>
           <p:cNvSpPr txBox="1"/>
           <p:nvPr/>
         </p:nvSpPr>
@@ -18370,7 +18712,7 @@
       </p:sp>
       <p:sp>
         <p:nvSpPr>
-          <p:cNvPr id="28" name="Oval 27"/>
+          <p:cNvPr id="34" name="Oval 33"/>
           <p:cNvSpPr/>
           <p:nvPr/>
         </p:nvSpPr>
@@ -18414,7 +18756,7 @@
       </p:sp>
       <p:sp>
         <p:nvSpPr>
-          <p:cNvPr id="29" name="TextBox 28"/>
+          <p:cNvPr id="35" name="TextBox 34"/>
           <p:cNvSpPr txBox="1"/>
           <p:nvPr/>
         </p:nvSpPr>
@@ -18449,7 +18791,7 @@
       </p:sp>
       <p:sp>
         <p:nvSpPr>
-          <p:cNvPr id="30" name="Oval 29"/>
+          <p:cNvPr id="36" name="Oval 35"/>
           <p:cNvSpPr/>
           <p:nvPr/>
         </p:nvSpPr>
@@ -18493,7 +18835,7 @@
       </p:sp>
       <p:sp>
         <p:nvSpPr>
-          <p:cNvPr id="31" name="TextBox 30"/>
+          <p:cNvPr id="37" name="TextBox 36"/>
           <p:cNvSpPr txBox="1"/>
           <p:nvPr/>
         </p:nvSpPr>
@@ -18528,7 +18870,7 @@
       </p:sp>
       <p:sp>
         <p:nvSpPr>
-          <p:cNvPr id="32" name="Oval 31"/>
+          <p:cNvPr id="38" name="Oval 37"/>
           <p:cNvSpPr/>
           <p:nvPr/>
         </p:nvSpPr>
@@ -18572,7 +18914,7 @@
       </p:sp>
       <p:sp>
         <p:nvSpPr>
-          <p:cNvPr id="33" name="TextBox 32"/>
+          <p:cNvPr id="39" name="TextBox 38"/>
           <p:cNvSpPr txBox="1"/>
           <p:nvPr/>
         </p:nvSpPr>
@@ -18607,7 +18949,7 @@
       </p:sp>
       <p:sp>
         <p:nvSpPr>
-          <p:cNvPr id="34" name="Oval 33"/>
+          <p:cNvPr id="40" name="Oval 39"/>
           <p:cNvSpPr/>
           <p:nvPr/>
         </p:nvSpPr>
@@ -18651,7 +18993,7 @@
       </p:sp>
       <p:sp>
         <p:nvSpPr>
-          <p:cNvPr id="35" name="TextBox 34"/>
+          <p:cNvPr id="41" name="TextBox 40"/>
           <p:cNvSpPr txBox="1"/>
           <p:nvPr/>
         </p:nvSpPr>
@@ -18686,7 +19028,7 @@
       </p:sp>
       <p:sp>
         <p:nvSpPr>
-          <p:cNvPr id="36" name="TextBox 35"/>
+          <p:cNvPr id="42" name="TextBox 41"/>
           <p:cNvSpPr txBox="1"/>
           <p:nvPr/>
         </p:nvSpPr>
@@ -29942,7 +30284,7 @@
                 </a:solidFill>
                 <a:latin typeface="Calibri"/>
               </a:rPr>
-              <a:t>Hold one part still and move the other: Q2's shares with Q1's rates isolates the mix, and what is left is the rate.</a:t>
+              <a:t>Hold one part still and move the other: Q2's shares with Q1's rates isolates the mix, and what is left is the rate. As with the morning's bridge, the order is a choice, so say which part moved first.</a:t>
             </a:r>
           </a:p>
         </p:txBody>
@@ -31255,8 +31597,8 @@
         </p:blipFill>
         <p:spPr>
           <a:xfrm>
-            <a:off x="2286863" y="1664208"/>
-            <a:ext cx="7617968" cy="3808984"/>
+            <a:off x="2563215" y="1664208"/>
+            <a:ext cx="7065264" cy="3532632"/>
           </a:xfrm>
           <a:prstGeom prst="rect">
             <a:avLst/>
@@ -31271,8 +31613,8 @@
         </p:nvSpPr>
         <p:spPr>
           <a:xfrm>
-            <a:off x="530352" y="5518912"/>
-            <a:ext cx="11130991" cy="680720"/>
+            <a:off x="530352" y="5242560"/>
+            <a:ext cx="11130991" cy="957072"/>
           </a:xfrm>
           <a:prstGeom prst="rect">
             <a:avLst/>
@@ -31292,7 +31634,7 @@
                 </a:solidFill>
                 <a:latin typeface="Calibri"/>
               </a:rPr>
-              <a:t>In rupees, Business is -Rs 22,29,720 of the Rs 23,00,000 fall, 97 percent of it on three fewer orders; Retail-Plus is -Rs 65,250, which is 93 percent of the consumer fall.</a:t>
+              <a:t>In rupees, Business is -Rs 22,29,720 of the Rs 23,00,000 fall, 97 percent of it on three fewer orders; Retail-Plus is -Rs 65,250, which is 93 percent of the consumer fall. The typical Business order barely moved (median Rs 9,83,780 to Rs 9,52,000), so the Business rupees are a count of three orders.</a:t>
             </a:r>
           </a:p>
         </p:txBody>

</xml_diff>

<commit_message>
W01 D2 exercises and Kahoot carry the new depth
Two items more per round set, a stretch item on each case brief and a
ninth Kahoot item on the bridge's step order, each with its key reasoned
in the solutions; the index, the letter shapes and the afternoon deck's
Kahoot slide follow.

Co-Authored-By: Claude Opus 5.5 <noreply@anthropic.com>
Claude-Session: https://claude.ai/code/session_011NVg1vHjDBgHjSC8kYZMtZ
</commit_message>
<xml_diff>
--- a/content/W01/D2/slides/C2_W01_D02_half2_STUDENT.pptx
+++ b/content/W01/D2/slides/C2_W01_D02_half2_STUDENT.pptx
@@ -23285,7 +23285,7 @@
                 </a:solidFill>
                 <a:latin typeface="Georgia"/>
               </a:rPr>
-              <a:t>Kahoot: eight questions, ungraded</a:t>
+              <a:t>Kahoot: nine questions, ungraded</a:t>
             </a:r>
           </a:p>
         </p:txBody>
@@ -23355,7 +23355,7 @@
                 </a:solidFill>
                 <a:latin typeface="Georgia"/>
               </a:rPr>
-              <a:t>8</a:t>
+              <a:t>9</a:t>
             </a:r>
           </a:p>
         </p:txBody>
@@ -23425,7 +23425,7 @@
                 </a:solidFill>
                 <a:latin typeface="Calibri"/>
               </a:rPr>
-              <a:t>seven from today, one from Monday</a:t>
+              <a:t>eight from today, one from Monday</a:t>
             </a:r>
           </a:p>
         </p:txBody>

</xml_diff>

<commit_message>
W01 D2: Anand's line quoted in the row's own words
The afternoon deck's S23, the pre-read and the board work now quote the
Wednesday row verbatim. The afternoon deck is rebuilt, which also carries
the Kahoot's eight items on S20 and the helper-drop check on S5.

Co-Authored-By: Claude Opus 5.5 <noreply@anthropic.com>
Claude-Session: https://claude.ai/code/session_01NDq7Sv6UNg6oqbgZGtNeM1
</commit_message>
<xml_diff>
--- a/content/W01/D2/slides/C2_W01_D02_half2_STUDENT.pptx
+++ b/content/W01/D2/slides/C2_W01_D02_half2_STUDENT.pptx
@@ -2910,12 +2910,22 @@
           </a:p>
           <a:p>
             <a:r>
-              <a:t>segments in against two rows out, or None in changes.values(). The fix: return the change on every</a:t>
-            </a:r>
-          </a:p>
-          <a:p>
-            <a:r>
-              <a:t>path and put the flag in a separate column. The comprehension is the colleague's code; the room</a:t>
+              <a:t>segments in and two came back as None, which None in changes.values() answers in one line. With the</a:t>
+            </a:r>
+          </a:p>
+          <a:p>
+            <a:r>
+              <a:t>helper fixed, the falls table holds three rows against the broken two, so the bug dropped one fall,</a:t>
+            </a:r>
+          </a:p>
+          <a:p>
+            <a:r>
+              <a:t>Retail-Plus; Student rose, and the filter leaves it out by design. The fix: return the change on</a:t>
+            </a:r>
+          </a:p>
+          <a:p>
+            <a:r>
+              <a:t>every path and put the flag in a separate column. The comprehension is the colleague's code; the room</a:t>
             </a:r>
           </a:p>
           <a:p>
@@ -23285,7 +23295,7 @@
                 </a:solidFill>
                 <a:latin typeface="Georgia"/>
               </a:rPr>
-              <a:t>Kahoot: nine questions, ungraded</a:t>
+              <a:t>Kahoot: eight questions, ungraded</a:t>
             </a:r>
           </a:p>
         </p:txBody>
@@ -23355,7 +23365,7 @@
                 </a:solidFill>
                 <a:latin typeface="Georgia"/>
               </a:rPr>
-              <a:t>9</a:t>
+              <a:t>8</a:t>
             </a:r>
           </a:p>
         </p:txBody>
@@ -23425,7 +23435,7 @@
                 </a:solidFill>
                 <a:latin typeface="Calibri"/>
               </a:rPr>
-              <a:t>eight from today, one from Monday</a:t>
+              <a:t>seven from today, one from Monday</a:t>
             </a:r>
           </a:p>
         </p:txBody>
@@ -26463,7 +26473,7 @@
                 </a:solidFill>
                 <a:latin typeface="Georgia"/>
               </a:rPr>
-              <a:t>"Your dashboard says Rs 2.1 crore for Q1 and my books say 1.9. Reconcile before anyone acts on tonight's numbers."</a:t>
+              <a:t>"Your dashboard says Q1 was Rs 2.1 crore. Our books say 1.9. Until your numbers match ours, Finance will not act on a drop measured from an ERP export. Send me a reconciliation."</a:t>
             </a:r>
           </a:p>
           <a:p>
@@ -32567,7 +32577,7 @@
       </p:sp>
       <p:pic>
         <p:nvPicPr>
-          <p:cNvPr id="14" name="mermaid diagram" descr="3bec39ac2ca0a938.png"/>
+          <p:cNvPr id="14" name="mermaid diagram" descr="b40a810b3dcb161a.png"/>
           <p:cNvPicPr>
             <a:picLocks noChangeAspect="1"/>
           </p:cNvPicPr>
@@ -32581,8 +32591,8 @@
         </p:blipFill>
         <p:spPr>
           <a:xfrm>
-            <a:off x="2309660" y="3336036"/>
-            <a:ext cx="7572375" cy="1128712"/>
+            <a:off x="1316678" y="3336036"/>
+            <a:ext cx="9558337" cy="1128712"/>
           </a:xfrm>
           <a:prstGeom prst="rect">
             <a:avLst/>

</xml_diff>

<commit_message>
W01/D2: depth-loop fixes from the rigor and pedagogy reviews: case TODO cells parse, keys written in their distractors' form, match and fix-the-logic items, minutes rebalanced, Swiggy in chapters 4 and 5, overstatements and reconciliation hints removed, one-page cheat sheet with all eight crux lines
Co-Authored-By: Claude Opus 5.5 <noreply@anthropic.com>
Claude-Session: https://claude.ai/code/session_015oxFsmPM6H7MXX1jsrhkTq
</commit_message>
<xml_diff>
--- a/content/W01/D2/slides/C2_W01_D02_half2_STUDENT.pptx
+++ b/content/W01/D2/slides/C2_W01_D02_half2_STUDENT.pptx
@@ -2296,7 +2296,7 @@
           <a:lstStyle/>
           <a:p>
             <a:r>
-              <a:t>LIVE, 2 minutes. The metric at stake is Retail-Plus orders per week before and after the break. Six</a:t>
+              <a:t>LIVE, 3 minutes. The metric at stake is Retail-Plus orders per week before and after the break. Six</a:t>
             </a:r>
           </a:p>
           <a:p>
@@ -2451,7 +2451,7 @@
           <a:lstStyle/>
           <a:p>
             <a:r>
-              <a:t>LIVE, 1 minute. Sources checked 30 Sep 2026: Sonos third quarter fiscal 2024 results (the chief</a:t>
+              <a:t>LIVE, 2 minutes. Sources checked 30 Sep 2026: Sonos third quarter fiscal 2024 results (the chief</a:t>
             </a:r>
           </a:p>
           <a:p>
@@ -21665,7 +21665,7 @@
                           </a:solidFill>
                           <a:latin typeface="Calibri"/>
                         </a:rPr>
-                        <a:t>No new customer; a rate on 2 moves 50 percent per order</a:t>
+                        <a:t>No new customer, and one order moves a rate on 2 customers by 20 percent</a:t>
                       </a:r>
                     </a:p>
                   </a:txBody>
@@ -26326,7 +26326,7 @@
                 </a:solidFill>
                 <a:latin typeface="Georgia"/>
               </a:rPr>
-              <a:t>"Revenue fell 11.0 percent between two closed quarters, Rs 2.10 crore to Rs 1.87 crore on the export as it stands. Customers held at 69, every one of them buying in both quarters, so acquisition is not the branch that moved; orders per customer fell from 1.65 to 1.25. In behaviour the fall sits in Retail-Plus, where the same 22 members placed 26 orders against 51, and revenue per order rose mainly because those small orders disappeared. In rupees most of it is three fewer Business orders, which tomorrow's reconciliation checks. The fall began in July, before the reorder button broke, so the button explains at most about 4 orders; we are asking for the tier's July change log and the app's reorder logs."</a:t>
+              <a:t>"Revenue fell 11.0 percent between two closed quarters, Rs 2.10 crore to Rs 1.87 crore on the export as it stands. Customers held at 69, every one of them buying in both quarters, so acquisition is not the branch that moved; orders per customer fell from 1.65 to 1.25. In behaviour the fall sits in Retail-Plus, where the same 22 members placed 26 orders against 51, and revenue per order rose mainly because those small orders disappeared. In rupees most of it is three fewer Business orders, each worth lakhs and too few to call a trend. The fall began in July, before the reorder button broke, so the button explains at most about 4 orders; we are asking for the tier's July change log and the app's reorder logs."</a:t>
             </a:r>
           </a:p>
           <a:p>
@@ -30224,7 +30224,7 @@
                 </a:solidFill>
                 <a:latin typeface="Georgia"/>
               </a:rPr>
-              <a:t>Sonos tied its app to revenue with evidence</a:t>
+              <a:t>Sonos tied an app rollout to its guidance</a:t>
             </a:r>
           </a:p>
         </p:txBody>
@@ -30259,7 +30259,7 @@
                 </a:solidFill>
                 <a:latin typeface="Calibri"/>
               </a:rPr>
-              <a:t>A loyal customer base, an app that broke, and a company that cut its guidance only once it had the numbers.</a:t>
+              <a:t>A loyal customer base, an app rollout that went wrong, and a company that put it into its guidance.</a:t>
             </a:r>
           </a:p>
         </p:txBody>
@@ -30294,7 +30294,7 @@
                 </a:solidFill>
                 <a:latin typeface="Georgia"/>
               </a:rPr>
-              <a:t>May 2024</a:t>
+              <a:t>2024</a:t>
             </a:r>
           </a:p>
         </p:txBody>
@@ -30329,7 +30329,7 @@
                 </a:solidFill>
                 <a:latin typeface="Calibri"/>
               </a:rPr>
-              <a:t>REDESIGNED APP SHIPPED</a:t>
+              <a:t>REDESIGNED APP ROLLED OUT</a:t>
             </a:r>
           </a:p>
         </p:txBody>
@@ -30364,7 +30364,7 @@
                 </a:solidFill>
                 <a:latin typeface="Calibri"/>
               </a:rPr>
-              <a:t>customers reported it broken</a:t>
+              <a:t>the problems it caused</a:t>
             </a:r>
           </a:p>
         </p:txBody>

</xml_diff>

<commit_message>
W01/D2: second-round depth-loop fixes: exercise twins no longer print or state their keys, remaining overstatements and the companion's reconciliation hint removed, option forms evened, two ordering items, taller cheat-sheet tree, afternoon minutes at 180
Co-Authored-By: Claude Opus 5.5 <noreply@anthropic.com>
Claude-Session: https://claude.ai/code/session_015oxFsmPM6H7MXX1jsrhkTq
</commit_message>
<xml_diff>
--- a/content/W01/D2/slides/C2_W01_D02_half2_STUDENT.pptx
+++ b/content/W01/D2/slides/C2_W01_D02_half2_STUDENT.pptx
@@ -1006,7 +1006,7 @@
           <a:lstStyle/>
           <a:p>
             <a:r>
-              <a:t>LIVE, 1 minute before work starts. Remind the room that the notebook stops at the first placeholder</a:t>
+              <a:t>LIVE, inside the 3-minute brief, before work starts. Remind the room that the notebook stops at the first placeholder</a:t>
             </a:r>
           </a:p>
           <a:p>
@@ -14721,7 +14721,7 @@
                 </a:solidFill>
                 <a:latin typeface="Calibri"/>
               </a:rPr>
-              <a:t>The booked overlap is 69, 0 and 0. The branch that moved is fulfilment, owned by operations, and acquisition still has nothing to replace.</a:t>
+              <a:t>The booked overlap is 69, 0 and 0. The branch that moved is cancellations and returns, to be split by reason, and acquisition still has nothing to replace.</a:t>
             </a:r>
           </a:p>
         </p:txBody>

</xml_diff>

<commit_message>
W01/D2: third-round depth-loop fixes: case TODO checks test outcomes so every wrong pick fails, options in parallel form, design items tagged, open-quarter call consistent, remaining overstatements rewritten
Co-Authored-By: Claude Opus 5.5 <noreply@anthropic.com>
Claude-Session: https://claude.ai/code/session_015oxFsmPM6H7MXX1jsrhkTq
</commit_message>
<xml_diff>
--- a/content/W01/D2/slides/C2_W01_D02_half2_STUDENT.pptx
+++ b/content/W01/D2/slides/C2_W01_D02_half2_STUDENT.pptx
@@ -531,7 +531,7 @@
           <a:lstStyle/>
           <a:p>
             <a:r>
-              <a:t>LIVE, one minute. The morning climbed five chapters: the drop is real at 11.0 percent, the branch is</a:t>
+              <a:t>LIVE, inside chapter 6's first minutes. The morning climbed five chapters: the drop is real at 11.0 percent, the branch is</a:t>
             </a:r>
           </a:p>
           <a:p>
@@ -1386,17 +1386,17 @@
           <a:lstStyle/>
           <a:p>
             <a:r>
-              <a:t>LIVE. Chapter 6 runs 30 minutes: 3 on the need and Sonos, 4 on the options, 4 on the monthly line, 8</a:t>
-            </a:r>
-          </a:p>
-          <a:p>
-            <a:r>
-              <a:t>on the trap and its ceiling, 5 on the season, the channel and the second route, 4 on the memo, 2 on</a:t>
-            </a:r>
-          </a:p>
-          <a:p>
-            <a:r>
-              <a:t>Kavya. Open notebooks/C2_W01_D02_06_the_memo_STUDENT.ipynb. The chapter opener is numbered 6 on</a:t>
+              <a:t>LIVE. Chapter 6 runs 30 minutes: 5 on the need and Sonos, 4 on the options, 4 on the monthly line, 8</a:t>
+            </a:r>
+          </a:p>
+          <a:p>
+            <a:r>
+              <a:t>on the trap and its ceiling, 5 on the season, the channel and the second route, 4 on the memo and</a:t>
+            </a:r>
+          </a:p>
+          <a:p>
+            <a:r>
+              <a:t>Kavya's review. Open notebooks/C2_W01_D02_06_the_memo_STUDENT.ipynb. The chapter opener is numbered 6 on</a:t>
             </a:r>
           </a:p>
           <a:p>
@@ -2686,12 +2686,7 @@
           <a:lstStyle/>
           <a:p>
             <a:r>
-              <a:t>LIVE, 2 minutes. The answer is c. The button may still matter; it cannot be the whole story. If a</a:t>
-            </a:r>
-          </a:p>
-          <a:p>
-            <a:r>
-              <a:t>learner points at May's 24, write "May, 24?" on the parking board for Wednesday and say nothing more.</a:t>
+              <a:t>LIVE, 2 minutes. The answer is c. The button may still matter; it cannot be the whole story. Keep to the Q2 months.</a:t>
             </a:r>
           </a:p>
         </p:txBody>
@@ -2766,7 +2761,7 @@
           </a:p>
           <a:p>
             <a:r>
-              <a:t>with seven weeks of orders lost before it broke.</a:t>
+              <a:t>with about eight weeks of orders lost before it broke.</a:t>
             </a:r>
           </a:p>
         </p:txBody>

</xml_diff>

<commit_message>
W01/D2: both decks rebuilt with the merged builder, so the afternoon's chapter 6 opener prints 06; the decks and day sheet carry the new second routes and the second case, lose Berkeley and the small-base lines, and gloss the business terms
The morning deck's S27, S39, S45 and S54 and the afternoon's S9, S17 and S18 are rebuilt around the
new material; S11's brief no longer names the escalated case's keys; S38's order-size stat reads
430x to match several hundredfold. The day sheet drops its renumbering step and its second-route and
second-case lines follow the new files. The tier ratio reads 0.545 counted directly and about 0.55
from the rounded leaves, everywhere. Notebook 3's forward pointer no longer frames Thursday as noise.
The provenance logs this review pass and the decisions it changed.

Co-Authored-By: Claude Opus 5.5 <noreply@anthropic.com>
Claude-Session: https://claude.ai/code/session_01P7zaoR4dQ5pzBFnsX549JQ
</commit_message>
<xml_diff>
--- a/content/W01/D2/slides/C2_W01_D02_half2_STUDENT.pptx
+++ b/content/W01/D2/slides/C2_W01_D02_half2_STUDENT.pptx
@@ -691,12 +691,22 @@
           <a:lstStyle/>
           <a:p>
             <a:r>
-              <a:t>LIVE, 2 minutes. The notebook draws the cumulative line against the pace and asserts the two routes</a:t>
-            </a:r>
-          </a:p>
-          <a:p>
-            <a:r>
-              <a:t>agree.</a:t>
+              <a:t>LIVE, 2 minutes. Retail-Core placed 22 orders in the 55 days before 25 August and 14 in the 37 after,</a:t>
+            </a:r>
+          </a:p>
+          <a:p>
+            <a:r>
+              <a:t>a pace 0.946 of what it had been. Scale the tier's expected 12.1 by it: 11.5, against 8 placed, about</a:t>
+            </a:r>
+          </a:p>
+          <a:p>
+            <a:r>
+              <a:t>3.5 orders. The route could have come out above the ceiling of 4.1 and lands below it, which is what</a:t>
+            </a:r>
+          </a:p>
+          <a:p>
+            <a:r>
+              <a:t>a ceiling predicts. The notebook also draws section 2's cumulative line against the pre-break pace.</a:t>
             </a:r>
           </a:p>
         </p:txBody>
@@ -1866,7 +1876,12 @@
           </a:p>
           <a:p>
             <a:r>
-              <a:t>2. Nobody can check it, compare it or know how many cases it rests on: 40 percent of five orders.</a:t>
+              <a:t>2. Nobody can check it or compare it: orders per customer is 1.25 over 69 booked customers and 1.14</a:t>
+            </a:r>
+          </a:p>
+          <a:p>
+            <a:r>
+              <a:t>over 50 delivered ones, so the denominator decides the number.</a:t>
             </a:r>
           </a:p>
           <a:p>
@@ -6832,7 +6847,7 @@
       </p:sp>
       <p:pic>
         <p:nvPicPr>
-          <p:cNvPr id="9" name="mermaid diagram" descr="1c13bac174197499.png"/>
+          <p:cNvPr id="9" name="mermaid diagram" descr="ee8eda15507f32b1.png"/>
           <p:cNvPicPr>
             <a:picLocks noChangeAspect="1"/>
           </p:cNvPicPr>
@@ -7701,7 +7716,7 @@
                 </a:solidFill>
                 <a:latin typeface="Georgia"/>
               </a:rPr>
-              <a:t>A second route: the pace the tier had set</a:t>
+              <a:t>A second route: the pace, corrected</a:t>
             </a:r>
           </a:p>
         </p:txBody>
@@ -7736,14 +7751,14 @@
                 </a:solidFill>
                 <a:latin typeface="Calibri"/>
               </a:rPr>
-              <a:t>Carry the pre-break pace forward and count the shortfall after the break: the same 4.1 orders.</a:t>
+              <a:t>Take out what slowed Retail-Core across the same date, and the button's share shrinks to about 3.5.</a:t>
             </a:r>
           </a:p>
         </p:txBody>
       </p:sp>
       <p:pic>
         <p:nvPicPr>
-          <p:cNvPr id="9" name="mermaid diagram" descr="cf313b1da446c501.png"/>
+          <p:cNvPr id="9" name="mermaid diagram" descr="4e3c2ff9ff805db1.png"/>
           <p:cNvPicPr>
             <a:picLocks noChangeAspect="1"/>
           </p:cNvPicPr>
@@ -7757,8 +7772,8 @@
         </p:blipFill>
         <p:spPr>
           <a:xfrm>
-            <a:off x="780897" y="1956816"/>
-            <a:ext cx="10629900" cy="1600200"/>
+            <a:off x="1209522" y="1956816"/>
+            <a:ext cx="9772650" cy="1128712"/>
           </a:xfrm>
           <a:prstGeom prst="rect">
             <a:avLst/>
@@ -7773,7 +7788,7 @@
         </p:nvSpPr>
         <p:spPr>
           <a:xfrm>
-            <a:off x="530352" y="3703320"/>
+            <a:off x="530352" y="3231832"/>
             <a:ext cx="11130991" cy="807720"/>
           </a:xfrm>
           <a:prstGeom prst="roundRect">
@@ -7821,7 +7836,7 @@
         </p:nvSpPr>
         <p:spPr>
           <a:xfrm>
-            <a:off x="676656" y="3831336"/>
+            <a:off x="676656" y="3359848"/>
             <a:ext cx="45720" cy="551688"/>
           </a:xfrm>
           <a:prstGeom prst="roundRect">
@@ -7867,7 +7882,7 @@
         </p:nvSpPr>
         <p:spPr>
           <a:xfrm>
-            <a:off x="877824" y="3822192"/>
+            <a:off x="877824" y="3350704"/>
             <a:ext cx="10564063" cy="624840"/>
           </a:xfrm>
           <a:prstGeom prst="rect">
@@ -7897,7 +7912,7 @@
                 </a:solidFill>
                 <a:latin typeface="Calibri"/>
               </a:rPr>
-              <a:t>Write the rate route in the memo; draw the counting route, since a line bending away from its own pace is what a room can see.</a:t>
+              <a:t>Write the ceiling in the memo; bring the corrected route when someone argues for the season.</a:t>
             </a:r>
           </a:p>
         </p:txBody>
@@ -8654,7 +8669,7 @@
       </p:sp>
       <p:pic>
         <p:nvPicPr>
-          <p:cNvPr id="9" name="mermaid diagram" descr="103ced1a8663a069.png"/>
+          <p:cNvPr id="9" name="mermaid diagram" descr="cfa4af3c787dbdc1.png"/>
           <p:cNvPicPr>
             <a:picLocks noChangeAspect="1"/>
           </p:cNvPicPr>
@@ -8668,8 +8683,8 @@
         </p:blipFill>
         <p:spPr>
           <a:xfrm>
-            <a:off x="982979" y="1682496"/>
-            <a:ext cx="3881071" cy="4517136"/>
+            <a:off x="530352" y="2749872"/>
+            <a:ext cx="4786326" cy="2382383"/>
           </a:xfrm>
           <a:prstGeom prst="rect">
             <a:avLst/>
@@ -10203,7 +10218,7 @@
                 </a:solidFill>
                 <a:latin typeface="Calibri"/>
               </a:rPr>
-              <a:t>Week 1 Tuesday: the cause on trial</a:t>
+              <a:t>Week 1, Day 2. The cause on trial</a:t>
             </a:r>
           </a:p>
         </p:txBody>
@@ -10479,7 +10494,7 @@
                 </a:solidFill>
                 <a:latin typeface="Calibri"/>
               </a:rPr>
-              <a:t>The board pack reports what reached customers and stayed, and one branch that held this morning moves.</a:t>
+              <a:t>The board pack, the numbers the board reads, counts only what reached customers and stayed.</a:t>
             </a:r>
           </a:p>
         </p:txBody>
@@ -11105,7 +11120,7 @@
         <p:spPr>
           <a:xfrm>
             <a:off x="2957718" y="4778756"/>
-            <a:ext cx="1750710" cy="531876"/>
+            <a:ext cx="1750710" cy="366776"/>
           </a:xfrm>
           <a:prstGeom prst="rect">
             <a:avLst/>
@@ -11126,7 +11141,7 @@
                 </a:solidFill>
                 <a:latin typeface="Calibri"/>
               </a:rPr>
-              <a:t>A bridge in the tree's order; one branch that held now moves.</a:t>
+              <a:t>A bridge in the tree's order, one leaf at a time.</a:t>
             </a:r>
           </a:p>
         </p:txBody>
@@ -11308,7 +11323,7 @@
         <p:spPr>
           <a:xfrm>
             <a:off x="5220492" y="4778756"/>
-            <a:ext cx="1750710" cy="366776"/>
+            <a:ext cx="1750710" cy="531876"/>
           </a:xfrm>
           <a:prstGeom prst="rect">
             <a:avLst/>
@@ -11329,7 +11344,7 @@
                 </a:solidFill>
                 <a:latin typeface="Calibri"/>
               </a:rPr>
-              <a:t>Compare the delivered and the booked overlap.</a:t>
+              <a:t>Find out what the customers who left the count did in Q2.</a:t>
             </a:r>
           </a:p>
         </p:txBody>
@@ -11497,7 +11512,7 @@
                 </a:solidFill>
                 <a:latin typeface="Calibri"/>
               </a:rPr>
-              <a:t>Four segments, rolled up</a:t>
+              <a:t>Four segments on delivered</a:t>
             </a:r>
           </a:p>
         </p:txBody>
@@ -11511,7 +11526,7 @@
         <p:spPr>
           <a:xfrm>
             <a:off x="7483266" y="4778756"/>
-            <a:ext cx="1750710" cy="366776"/>
+            <a:ext cx="1750710" cy="531876"/>
           </a:xfrm>
           <a:prstGeom prst="rect">
             <a:avLst/>
@@ -11532,7 +11547,7 @@
                 </a:solidFill>
                 <a:latin typeface="Calibri"/>
               </a:rPr>
-              <a:t>tree_for, the weighted roll-up, every group counted.</a:t>
+              <a:t>tree_for per segment, the rate rolled up, every group counted.</a:t>
             </a:r>
           </a:p>
         </p:txBody>
@@ -14279,7 +14294,7 @@
                 </a:solidFill>
                 <a:latin typeface="Calibri"/>
               </a:rPr>
-              <a:t>Week 1 Tuesday: the cause on trial</a:t>
+              <a:t>Week 1, Day 2. The cause on trial</a:t>
             </a:r>
           </a:p>
         </p:txBody>
@@ -14562,7 +14577,7 @@
       </p:sp>
       <p:pic>
         <p:nvPicPr>
-          <p:cNvPr id="9" name="mermaid diagram" descr="c53971bbbe6166de.png"/>
+          <p:cNvPr id="9" name="mermaid diagram" descr="3fe3c6a4f48645f0.png"/>
           <p:cNvPicPr>
             <a:picLocks noChangeAspect="1"/>
           </p:cNvPicPr>
@@ -14576,8 +14591,8 @@
         </p:blipFill>
         <p:spPr>
           <a:xfrm>
-            <a:off x="780897" y="1956816"/>
-            <a:ext cx="10629900" cy="1357312"/>
+            <a:off x="666597" y="1956816"/>
+            <a:ext cx="10858500" cy="871537"/>
           </a:xfrm>
           <a:prstGeom prst="rect">
             <a:avLst/>
@@ -14592,7 +14607,7 @@
         </p:nvSpPr>
         <p:spPr>
           <a:xfrm>
-            <a:off x="530352" y="3460432"/>
+            <a:off x="530352" y="2974657"/>
             <a:ext cx="11130991" cy="807720"/>
           </a:xfrm>
           <a:prstGeom prst="roundRect">
@@ -14640,7 +14655,7 @@
         </p:nvSpPr>
         <p:spPr>
           <a:xfrm>
-            <a:off x="676656" y="3588448"/>
+            <a:off x="676656" y="3102673"/>
             <a:ext cx="45720" cy="551688"/>
           </a:xfrm>
           <a:prstGeom prst="roundRect">
@@ -14686,7 +14701,7 @@
         </p:nvSpPr>
         <p:spPr>
           <a:xfrm>
-            <a:off x="877824" y="3579304"/>
+            <a:off x="877824" y="3093529"/>
             <a:ext cx="10564063" cy="624840"/>
           </a:xfrm>
           <a:prstGeom prst="rect">
@@ -15473,7 +15488,7 @@
       </p:sp>
       <p:pic>
         <p:nvPicPr>
-          <p:cNvPr id="9" name="mermaid diagram" descr="4a03608887a649cb.png"/>
+          <p:cNvPr id="9" name="mermaid diagram" descr="2f6362d59040854e.png"/>
           <p:cNvPicPr>
             <a:picLocks noChangeAspect="1"/>
           </p:cNvPicPr>
@@ -17962,7 +17977,7 @@
                 </a:solidFill>
                 <a:latin typeface="Calibri"/>
               </a:rPr>
-              <a:t>Week 1 Tuesday: the cause on trial</a:t>
+              <a:t>Week 1, Day 2. The cause on trial</a:t>
             </a:r>
           </a:p>
         </p:txBody>
@@ -18245,7 +18260,7 @@
       </p:sp>
       <p:pic>
         <p:nvPicPr>
-          <p:cNvPr id="9" name="mermaid diagram" descr="42df9b6a0735c156.png"/>
+          <p:cNvPr id="9" name="mermaid diagram" descr="19cba92fe2b2741c.png"/>
           <p:cNvPicPr>
             <a:picLocks noChangeAspect="1"/>
           </p:cNvPicPr>
@@ -18259,8 +18274,8 @@
         </p:blipFill>
         <p:spPr>
           <a:xfrm>
-            <a:off x="3607649" y="1664208"/>
-            <a:ext cx="4976396" cy="2944368"/>
+            <a:off x="3731266" y="1956816"/>
+            <a:ext cx="4729162" cy="2300287"/>
           </a:xfrm>
           <a:prstGeom prst="rect">
             <a:avLst/>
@@ -18275,7 +18290,7 @@
         </p:nvSpPr>
         <p:spPr>
           <a:xfrm>
-            <a:off x="530352" y="4654296"/>
+            <a:off x="530352" y="4403407"/>
             <a:ext cx="11130991" cy="1380744"/>
           </a:xfrm>
           <a:prstGeom prst="roundRect">
@@ -18329,7 +18344,7 @@
         </p:nvSpPr>
         <p:spPr>
           <a:xfrm>
-            <a:off x="758952" y="5116068"/>
+            <a:off x="758952" y="4865179"/>
             <a:ext cx="457200" cy="457200"/>
           </a:xfrm>
           <a:prstGeom prst="ellipse">
@@ -18381,7 +18396,7 @@
         </p:blipFill>
         <p:spPr>
           <a:xfrm>
-            <a:off x="868680" y="5225796"/>
+            <a:off x="868680" y="4974907"/>
             <a:ext cx="237744" cy="237744"/>
           </a:xfrm>
           <a:prstGeom prst="rect">
@@ -18397,7 +18412,7 @@
         </p:nvSpPr>
         <p:spPr>
           <a:xfrm>
-            <a:off x="1399031" y="4800600"/>
+            <a:off x="1399031" y="4549711"/>
             <a:ext cx="9987991" cy="160401"/>
           </a:xfrm>
           <a:prstGeom prst="rect">
@@ -18432,7 +18447,7 @@
         </p:nvSpPr>
         <p:spPr>
           <a:xfrm>
-            <a:off x="1399031" y="5020056"/>
+            <a:off x="1399031" y="4769167"/>
             <a:ext cx="9987991" cy="941832"/>
           </a:xfrm>
           <a:prstGeom prst="rect">
@@ -18453,7 +18468,7 @@
                 </a:solidFill>
                 <a:latin typeface="Calibri"/>
               </a:rPr>
-              <a:t>"On delivered orders the story held: frequency, Retail-Plus at minus 42.6 percent per member, and the same two hypotheses. The branch that moved was fulfilment. Put the definition beside every number, and the solution is open now."</a:t>
+              <a:t>"On delivered orders the story held: frequency, Retail-Plus at minus 42.6 percent per member, and the same two hypotheses. The branch that moved was fulfilment, getting orders to customers intact. Put the definition beside every number, and the solution is open now."</a:t>
             </a:r>
           </a:p>
         </p:txBody>
@@ -19603,7 +19618,7 @@
                 </a:solidFill>
                 <a:latin typeface="Calibri"/>
               </a:rPr>
-              <a:t>Week 1 Tuesday: the cause on trial</a:t>
+              <a:t>Week 1, Day 2. The cause on trial</a:t>
             </a:r>
           </a:p>
         </p:txBody>
@@ -20071,7 +20086,7 @@
                 </a:solidFill>
                 <a:latin typeface="Calibri"/>
               </a:rPr>
-              <a:t>Student rose 40 percent</a:t>
+              <a:t>7 percent more per order</a:t>
             </a:r>
           </a:p>
         </p:txBody>
@@ -20106,7 +20121,7 @@
                 </a:solidFill>
                 <a:latin typeface="Calibri"/>
               </a:rPr>
-              <a:t>"Our campus push worked, so acquisition works."</a:t>
+              <a:t>"Members spend more each time, so the tier is healthy."</a:t>
             </a:r>
           </a:p>
         </p:txBody>
@@ -21522,7 +21537,7 @@
         </p:nvGraphicFramePr>
         <p:xfrm>
           <a:off x="530352" y="1956816"/>
-          <a:ext cx="11130989" cy="1962912"/>
+          <a:ext cx="11130990" cy="1962912"/>
         </p:xfrm>
         <a:graphic>
           <a:graphicData uri="http://schemas.openxmlformats.org/drawingml/2006/table">
@@ -21531,9 +21546,9 @@
                 <a:tableStyleId>{2D5ABB26-0587-4C30-8999-92F81FD0307C}</a:tableStyleId>
               </a:tblPr>
               <a:tblGrid>
-                <a:gridCol w="1855937"/>
-                <a:gridCol w="4025600"/>
-                <a:gridCol w="5249452"/>
+                <a:gridCol w="1993038"/>
+                <a:gridCol w="4568976"/>
+                <a:gridCol w="4568976"/>
               </a:tblGrid>
               <a:tr h="369824">
                 <a:tc>
@@ -21616,7 +21631,7 @@
                           </a:solidFill>
                           <a:latin typeface="Calibri"/>
                         </a:rPr>
-                        <a:t>Student +40 percent</a:t>
+                        <a:t>7 percent more per order</a:t>
                       </a:r>
                     </a:p>
                   </a:txBody>
@@ -21638,7 +21653,7 @@
                           </a:solidFill>
                           <a:latin typeface="Calibri"/>
                         </a:rPr>
-                        <a:t>The same 2 customers, 5 orders to 7</a:t>
+                        <a:t>The same 22 members at about half the orders: 1.000 x 0.510 x 1.070, about 0.55</a:t>
                       </a:r>
                     </a:p>
                   </a:txBody>
@@ -21660,7 +21675,7 @@
                           </a:solidFill>
                           <a:latin typeface="Calibri"/>
                         </a:rPr>
-                        <a:t>No new customer, and one order moves a rate on 2 customers by 20 percent</a:t>
+                        <a:t>Tier revenue fell about 45 percent; one leaf that rose is not the tier</a:t>
                       </a:r>
                     </a:p>
                   </a:txBody>
@@ -23093,7 +23108,7 @@
                 </a:solidFill>
                 <a:latin typeface="Calibri"/>
               </a:rPr>
-              <a:t>Week 1 Tuesday: the cause on trial</a:t>
+              <a:t>Week 1, Day 2. The cause on trial</a:t>
             </a:r>
           </a:p>
         </p:txBody>
@@ -25965,7 +25980,7 @@
                 </a:solidFill>
                 <a:latin typeface="Calibri"/>
               </a:rPr>
-              <a:t>Week 1 Tuesday: the cause on trial</a:t>
+              <a:t>Week 1, Day 2. The cause on trial</a:t>
             </a:r>
           </a:p>
         </p:txBody>
@@ -26321,7 +26336,7 @@
                 </a:solidFill>
                 <a:latin typeface="Georgia"/>
               </a:rPr>
-              <a:t>"Revenue fell 11.0 percent between two closed quarters, Rs 2.10 crore to Rs 1.87 crore on the export as it stands. Customers held at 69, every one of them buying in both quarters, so acquisition is not the branch that moved; orders per customer fell from 1.65 to 1.25. In behaviour the fall sits in Retail-Plus, where the same 22 members placed 26 orders against 51, and revenue per order rose mainly because those small orders disappeared. In rupees most of it is three fewer Business orders, each worth lakhs and too few to call a trend. The fall began in July, before the reorder button broke, so the button explains at most about 4 orders; we are asking for the tier's July change log and the app's reorder logs."</a:t>
+              <a:t>"Revenue fell 11.0 percent between two closed quarters, Rs 2.10 crore to Rs 1.87 crore on the export as it stands. Customers held at 69, every one of them buying in both quarters, so acquisition is not the branch that moved; orders per customer fell from 1.65 to 1.25. In behaviour the fall sits in Retail-Plus, where the same 22 members placed 26 orders against 51, and revenue per order rose mainly because those small orders disappeared. In rupees most of it is three fewer Business orders, each worth lakhs, so one account's timing moves it by lakhs. The fall began in July, before the reorder button broke, so the button explains at most about 4 orders; we are asking for the tier's July change log and the app's reorder logs."</a:t>
             </a:r>
           </a:p>
           <a:p>
@@ -27646,7 +27661,7 @@
       </p:sp>
       <p:pic>
         <p:nvPicPr>
-          <p:cNvPr id="25" name="mermaid diagram" descr="9035c65d03ba2779.png"/>
+          <p:cNvPr id="25" name="mermaid diagram" descr="49aae674ce3cc913.png"/>
           <p:cNvPicPr>
             <a:picLocks noChangeAspect="1"/>
           </p:cNvPicPr>
@@ -27660,8 +27675,8 @@
         </p:blipFill>
         <p:spPr>
           <a:xfrm>
-            <a:off x="794702" y="5327904"/>
-            <a:ext cx="10602289" cy="1097280"/>
+            <a:off x="3616966" y="5327904"/>
+            <a:ext cx="4957762" cy="871537"/>
           </a:xfrm>
           <a:prstGeom prst="rect">
             <a:avLst/>
@@ -28617,7 +28632,7 @@
       </p:sp>
       <p:pic>
         <p:nvPicPr>
-          <p:cNvPr id="14" name="mermaid diagram" descr="3c9d316c87502d4c.png"/>
+          <p:cNvPr id="14" name="mermaid diagram" descr="6d7380f3bb203e04.png"/>
           <p:cNvPicPr>
             <a:picLocks noChangeAspect="1"/>
           </p:cNvPicPr>
@@ -28631,8 +28646,8 @@
         </p:blipFill>
         <p:spPr>
           <a:xfrm>
-            <a:off x="2152497" y="3243072"/>
-            <a:ext cx="7886700" cy="1600200"/>
+            <a:off x="2745428" y="3243072"/>
+            <a:ext cx="6700837" cy="871537"/>
           </a:xfrm>
           <a:prstGeom prst="rect">
             <a:avLst/>
@@ -29487,7 +29502,7 @@
       </p:sp>
       <p:pic>
         <p:nvPicPr>
-          <p:cNvPr id="11" name="mermaid diagram" descr="c624ac5c6ae12194.png"/>
+          <p:cNvPr id="11" name="mermaid diagram" descr="f7113391a8911ae4.png"/>
           <p:cNvPicPr>
             <a:picLocks noChangeAspect="1"/>
           </p:cNvPicPr>
@@ -29501,8 +29516,8 @@
         </p:blipFill>
         <p:spPr>
           <a:xfrm>
-            <a:off x="3524097" y="3129280"/>
-            <a:ext cx="5143500" cy="2786062"/>
+            <a:off x="3745553" y="3129280"/>
+            <a:ext cx="4700587" cy="1800225"/>
           </a:xfrm>
           <a:prstGeom prst="rect">
             <a:avLst/>
@@ -30254,7 +30269,7 @@
                 </a:solidFill>
                 <a:latin typeface="Calibri"/>
               </a:rPr>
-              <a:t>A loyal customer base, an app rollout that went wrong, and a company that put it into its guidance.</a:t>
+              <a:t>A loyal customer base, an app rollout gone wrong, and a cut in guidance, the revenue promised to investors.</a:t>
             </a:r>
           </a:p>
         </p:txBody>
@@ -32867,7 +32882,7 @@
       </p:sp>
       <p:pic>
         <p:nvPicPr>
-          <p:cNvPr id="9" name="mermaid diagram" descr="e1a2c198c224d605.png"/>
+          <p:cNvPr id="9" name="mermaid diagram" descr="54c2b0eb5abb27a0.png"/>
           <p:cNvPicPr>
             <a:picLocks noChangeAspect="1"/>
           </p:cNvPicPr>
@@ -32881,8 +32896,8 @@
         </p:blipFill>
         <p:spPr>
           <a:xfrm>
-            <a:off x="2152497" y="1956816"/>
-            <a:ext cx="7886700" cy="1600200"/>
+            <a:off x="3074041" y="1956816"/>
+            <a:ext cx="6043612" cy="871537"/>
           </a:xfrm>
           <a:prstGeom prst="rect">
             <a:avLst/>
@@ -32897,7 +32912,7 @@
         </p:nvSpPr>
         <p:spPr>
           <a:xfrm>
-            <a:off x="530352" y="3703320"/>
+            <a:off x="530352" y="2974657"/>
             <a:ext cx="11130991" cy="541020"/>
           </a:xfrm>
           <a:prstGeom prst="roundRect">
@@ -32945,7 +32960,7 @@
         </p:nvSpPr>
         <p:spPr>
           <a:xfrm>
-            <a:off x="676656" y="3831336"/>
+            <a:off x="676656" y="3102673"/>
             <a:ext cx="45720" cy="284988"/>
           </a:xfrm>
           <a:prstGeom prst="roundRect">
@@ -32991,7 +33006,7 @@
         </p:nvSpPr>
         <p:spPr>
           <a:xfrm>
-            <a:off x="877824" y="3822192"/>
+            <a:off x="877824" y="3093529"/>
             <a:ext cx="10564063" cy="358140"/>
           </a:xfrm>
           <a:prstGeom prst="rect">
@@ -33778,7 +33793,7 @@
       </p:sp>
       <p:pic>
         <p:nvPicPr>
-          <p:cNvPr id="9" name="mermaid diagram" descr="70e24821516b80ec.png"/>
+          <p:cNvPr id="9" name="mermaid diagram" descr="bba7da84cfbe1350.png"/>
           <p:cNvPicPr>
             <a:picLocks noChangeAspect="1"/>
           </p:cNvPicPr>

</xml_diff>

<commit_message>
W01 D2 decks rebuilt after the fresh review: questions and answers in the ladder's words, the memo names both ceiling baselines, and the notes carry the drill's twelve questions
The morning deck drops its last claim label, asks chapter 4's sixth question in full and labels it
the same way on the map and the close. The afternoon memo quote states the ceiling on the 55 days
before the break and on the 37 days just before it. The notes fold the thirteenth interview
question into the twelfth, so the notes, the drill and the day sheet list the same twelve.

Co-Authored-By: Claude Opus 5.5 <noreply@anthropic.com>
Claude-Session: https://claude.ai/code/session_01Hb9A6qKwU75M1ZPNLDhr3q
</commit_message>
<xml_diff>
--- a/content/W01/D2/slides/C2_W01_D02_half2_STUDENT.pptx
+++ b/content/W01/D2/slides/C2_W01_D02_half2_STUDENT.pptx
@@ -1028,7 +1028,7 @@
           <a:lstStyle/>
           <a:p>
             <a:r>
-              <a:t>LIVE, 3 minutes. Two predictions tested, two rivals capped. July opens the monsoon quarter, so a</a:t>
+              <a:t>LIVE, 3 minutes. Both predictions fail, so both rival causes are capped. July opens the monsoon quarter, so a</a:t>
             </a:r>
           </a:p>
           <a:p>
@@ -1278,12 +1278,22 @@
           <a:lstStyle/>
           <a:p>
             <a:r>
-              <a:t>LIVE, 1 minute. One breath: restate as a hypothesis, test timing, then the comparison and the</a:t>
-            </a:r>
-          </a:p>
-          <a:p>
-            <a:r>
-              <a:t>channel, cap it, and name the data that settles it. The ceiling's baseline goes in the same breath:</a:t>
+              <a:t>LIVE, 1 minute. The interview tags: [S] a staple asked everywhere, [F] frequent in GCC and product</a:t>
+            </a:r>
+          </a:p>
+          <a:p>
+            <a:r>
+              <a:t>screens, [SV] a service-major screen opener, [D] a differentiator. One breath: restate as a</a:t>
+            </a:r>
+          </a:p>
+          <a:p>
+            <a:r>
+              <a:t>hypothesis, test timing, then the comparison and the channel, cap it, and name the data that</a:t>
+            </a:r>
+          </a:p>
+          <a:p>
+            <a:r>
+              <a:t>settles it. The ceiling's baseline goes in the same breath:</a:t>
             </a:r>
           </a:p>
           <a:p>
@@ -2298,12 +2308,7 @@
           </a:p>
           <a:p>
             <a:r>
-              <a:t>close. Open notebooks/C2_W01_D02_06_the_memo_STUDENT.ipynb. The chapter opener is numbered 6 on</a:t>
-            </a:r>
-          </a:p>
-          <a:p>
-            <a:r>
-              <a:t>purpose; it continues the morning's five.</a:t>
+              <a:t>close. Open notebooks/C2_W01_D02_06_the_memo_STUDENT.ipynb.</a:t>
             </a:r>
           </a:p>
         </p:txBody>
@@ -2833,17 +2838,17 @@
           <a:lstStyle/>
           <a:p>
             <a:r>
-              <a:t>LIVE, 2 minutes after the Kahoot. Read it aloud once, slowly. The "at most about 4" is on the tier's</a:t>
-            </a:r>
-          </a:p>
-          <a:p>
-            <a:r>
-              <a:t>pace over the 55 days before the break; on the 37 days just before it the ceiling is 7.0, and either</a:t>
-            </a:r>
-          </a:p>
-          <a:p>
-            <a:r>
-              <a:t>way it is far below the 25 a hurried memo charges. Ask one learner which part their own sentence</a:t>
+              <a:t>LIVE, 2 minutes after the Kahoot. Read it aloud once, slowly. The memo names both baselines, the</a:t>
+            </a:r>
+          </a:p>
+          <a:p>
+            <a:r>
+              <a:t>tier's pace over the 55 days before the break and over the 37 days just before it, and either way</a:t>
+            </a:r>
+          </a:p>
+          <a:p>
+            <a:r>
+              <a:t>the ceiling is far below the 25 a hurried memo charges. Ask one learner which part their own sentence</a:t>
             </a:r>
           </a:p>
           <a:p>
@@ -3238,12 +3243,12 @@
           </a:p>
           <a:p>
             <a:r>
-              <a:t>2024 annual report on Form 10-K (short-term costs of up to $30 million). No revenue figure for the</a:t>
-            </a:r>
-          </a:p>
-          <a:p>
-            <a:r>
-              <a:t>app's effect was verified on a primary page, so none is quoted. Then four ways to test a cause.</a:t>
+              <a:t>2024 annual report on Form 10-K (short-term costs of up to $30 million). Quote no revenue figure for</a:t>
+            </a:r>
+          </a:p>
+          <a:p>
+            <a:r>
+              <a:t>the app's effect; no primary page gives one. Then four ways to test a cause.</a:t>
             </a:r>
           </a:p>
         </p:txBody>
@@ -8445,7 +8450,7 @@
       </p:sp>
       <p:pic>
         <p:nvPicPr>
-          <p:cNvPr id="9" name="mermaid diagram" descr="70e24821516b80ec.png"/>
+          <p:cNvPr id="9" name="mermaid diagram" descr="f396a61352d03ecc.png"/>
           <p:cNvPicPr>
             <a:picLocks noChangeAspect="1"/>
           </p:cNvPicPr>
@@ -11271,7 +11276,7 @@
                 </a:solidFill>
                 <a:latin typeface="Calibri"/>
               </a:rPr>
-              <a:t>The check</a:t>
+              <a:t>The check.</a:t>
             </a:r>
             <a:r>
               <a:rPr sz="1500" b="0" i="0">
@@ -11280,7 +11285,7 @@
                 </a:solidFill>
                 <a:latin typeface="Calibri"/>
               </a:rPr>
-              <a:t> is chapter 1's lesson: a rate with its window.</a:t>
+              <a:t> Chapter 1's lesson: a rate with its window.</a:t>
             </a:r>
           </a:p>
         </p:txBody>
@@ -12045,7 +12050,7 @@
         </p:nvGraphicFramePr>
         <p:xfrm>
           <a:off x="530352" y="1956816"/>
-          <a:ext cx="11130990" cy="1341120"/>
+          <a:ext cx="11130989" cy="1341120"/>
         </p:xfrm>
         <a:graphic>
           <a:graphicData uri="http://schemas.openxmlformats.org/drawingml/2006/table">
@@ -12054,11 +12059,11 @@
                 <a:tableStyleId>{2D5ABB26-0587-4C30-8999-92F81FD0307C}</a:tableStyleId>
               </a:tblPr>
               <a:tblGrid>
-                <a:gridCol w="2877049"/>
+                <a:gridCol w="2331897"/>
                 <a:gridCol w="914400"/>
-                <a:gridCol w="3651647"/>
+                <a:gridCol w="2959721"/>
                 <a:gridCol w="914400"/>
-                <a:gridCol w="2773494"/>
+                <a:gridCol w="4010571"/>
               </a:tblGrid>
               <a:tr h="335280">
                 <a:tc>
@@ -12273,7 +12278,7 @@
                           </a:solidFill>
                           <a:latin typeface="Calibri"/>
                         </a:rPr>
-                        <a:t>about 4, about Rs 12,400</a:t>
+                        <a:t>about 4, about Rs 12,400 at Rs 3,012 an order</a:t>
                       </a:r>
                     </a:p>
                   </a:txBody>
@@ -13329,7 +13334,7 @@
                 </a:solidFill>
                 <a:latin typeface="Georgia"/>
               </a:rPr>
-              <a:t>Neither a season nor an app-only fault fits</a:t>
+              <a:t>A season for everyone and an app-only fault both fail</a:t>
             </a:r>
           </a:p>
         </p:txBody>
@@ -13371,7 +13376,7 @@
       </p:sp>
       <p:pic>
         <p:nvPicPr>
-          <p:cNvPr id="9" name="mermaid diagram" descr="1c13bac174197499.png"/>
+          <p:cNvPr id="9" name="mermaid diagram" descr="66fa8fcac61df626.png"/>
           <p:cNvPicPr>
             <a:picLocks noChangeAspect="1"/>
           </p:cNvPicPr>
@@ -13385,8 +13390,8 @@
         </p:blipFill>
         <p:spPr>
           <a:xfrm>
-            <a:off x="2845155" y="1664208"/>
-            <a:ext cx="6501384" cy="3250692"/>
+            <a:off x="2563215" y="1664208"/>
+            <a:ext cx="7065263" cy="3532631"/>
           </a:xfrm>
           <a:prstGeom prst="rect">
             <a:avLst/>
@@ -13395,67 +13400,51 @@
       </p:pic>
       <p:sp>
         <p:nvSpPr>
-          <p:cNvPr id="10" name="Rounded Rectangle 9"/>
+          <p:cNvPr id="10" name="TextBox 9"/>
+          <p:cNvSpPr txBox="1"/>
+          <p:nvPr/>
+        </p:nvSpPr>
+        <p:spPr>
+          <a:xfrm>
+            <a:off x="530352" y="5242560"/>
+            <a:ext cx="11130991" cy="957072"/>
+          </a:xfrm>
+          <a:prstGeom prst="rect">
+            <a:avLst/>
+          </a:prstGeom>
+          <a:noFill/>
+        </p:spPr>
+        <p:txBody>
+          <a:bodyPr wrap="square" anchor="t" lIns="0" rIns="0" tIns="0" bIns="0">
+            <a:spAutoFit/>
+          </a:bodyPr>
+          <a:lstStyle/>
+          <a:p>
+            <a:r>
+              <a:rPr sz="1600" b="0" i="0">
+                <a:solidFill>
+                  <a:srgbClr val="1A1440"/>
+                </a:solidFill>
+                <a:latin typeface="Calibri"/>
+              </a:rPr>
+              <a:t>Retail-Core kept 95 percent of its Q1 orders and Retail-Plus 51, so a season that hit every customer does not fit; every channel fell, so an app-only cause does not fit. A season that hit members harder still fits, and last year's Q2 by segment tests it.</a:t>
+            </a:r>
+          </a:p>
+        </p:txBody>
+      </p:sp>
+      <p:sp>
+        <p:nvSpPr>
+          <p:cNvPr id="11" name="Oval 10"/>
           <p:cNvSpPr/>
           <p:nvPr/>
         </p:nvSpPr>
         <p:spPr>
           <a:xfrm>
-            <a:off x="530352" y="4960620"/>
-            <a:ext cx="11130991" cy="1074420"/>
-          </a:xfrm>
-          <a:prstGeom prst="roundRect">
-            <a:avLst>
-              <a:gd name="adj" fmla="val 8000"/>
-            </a:avLst>
-          </a:prstGeom>
-          <a:solidFill>
-            <a:srgbClr val="F7F5FD"/>
-          </a:solidFill>
-          <a:ln w="9525">
-            <a:solidFill>
-              <a:srgbClr val="E4E1F1"/>
-            </a:solidFill>
-          </a:ln>
-          <a:effectLst/>
-        </p:spPr>
-        <p:style>
-          <a:lnRef idx="1">
-            <a:schemeClr val="accent1"/>
-          </a:lnRef>
-          <a:fillRef idx="3">
-            <a:schemeClr val="accent1"/>
-          </a:fillRef>
-          <a:effectRef idx="2">
-            <a:schemeClr val="accent1"/>
-          </a:effectRef>
-          <a:fontRef idx="minor">
-            <a:schemeClr val="lt1"/>
-          </a:fontRef>
-        </p:style>
-        <p:txBody>
-          <a:bodyPr rtlCol="0" anchor="ctr" wrap="square"/>
-          <a:lstStyle/>
-          <a:p>
-            <a:pPr algn="ctr"/>
-          </a:p>
-        </p:txBody>
-      </p:sp>
-      <p:sp>
-        <p:nvSpPr>
-          <p:cNvPr id="11" name="Rounded Rectangle 10"/>
-          <p:cNvSpPr/>
-          <p:nvPr/>
-        </p:nvSpPr>
-        <p:spPr>
-          <a:xfrm>
-            <a:off x="676656" y="5088636"/>
-            <a:ext cx="45720" cy="818388"/>
-          </a:xfrm>
-          <a:prstGeom prst="roundRect">
-            <a:avLst>
-              <a:gd name="adj" fmla="val 50000"/>
-            </a:avLst>
+            <a:off x="530352" y="6492240"/>
+            <a:ext cx="64008" cy="64008"/>
+          </a:xfrm>
+          <a:prstGeom prst="ellipse">
+            <a:avLst/>
           </a:prstGeom>
           <a:solidFill>
             <a:srgbClr val="5B3FD6"/>
@@ -13495,93 +13484,6 @@
         </p:nvSpPr>
         <p:spPr>
           <a:xfrm>
-            <a:off x="877824" y="5079492"/>
-            <a:ext cx="10564063" cy="891540"/>
-          </a:xfrm>
-          <a:prstGeom prst="rect">
-            <a:avLst/>
-          </a:prstGeom>
-          <a:noFill/>
-        </p:spPr>
-        <p:txBody>
-          <a:bodyPr wrap="square" anchor="ctr" lIns="0" rIns="0" tIns="0" bIns="0">
-            <a:spAutoFit/>
-          </a:bodyPr>
-          <a:lstStyle/>
-          <a:p>
-            <a:r>
-              <a:rPr sz="1500" b="1">
-                <a:solidFill>
-                  <a:srgbClr val="5B3FD6"/>
-                </a:solidFill>
-                <a:latin typeface="Calibri"/>
-              </a:rPr>
-              <a:t>What it says. </a:t>
-            </a:r>
-            <a:r>
-              <a:rPr sz="1500" b="0" i="0">
-                <a:solidFill>
-                  <a:srgbClr val="1A1440"/>
-                </a:solidFill>
-                <a:latin typeface="Calibri"/>
-              </a:rPr>
-              <a:t>Retail-Core kept 95 percent of its Q1 orders and Retail-Plus 51, so an across-the-board season does not fit; every channel fell, so an app-only cause does not fit. A season that hit members harder still fits, and last year's Q2 by segment tests it.</a:t>
-            </a:r>
-          </a:p>
-        </p:txBody>
-      </p:sp>
-      <p:sp>
-        <p:nvSpPr>
-          <p:cNvPr id="13" name="Oval 12"/>
-          <p:cNvSpPr/>
-          <p:nvPr/>
-        </p:nvSpPr>
-        <p:spPr>
-          <a:xfrm>
-            <a:off x="530352" y="6492240"/>
-            <a:ext cx="64008" cy="64008"/>
-          </a:xfrm>
-          <a:prstGeom prst="ellipse">
-            <a:avLst/>
-          </a:prstGeom>
-          <a:solidFill>
-            <a:srgbClr val="5B3FD6"/>
-          </a:solidFill>
-          <a:ln>
-            <a:noFill/>
-          </a:ln>
-          <a:effectLst/>
-        </p:spPr>
-        <p:style>
-          <a:lnRef idx="1">
-            <a:schemeClr val="accent1"/>
-          </a:lnRef>
-          <a:fillRef idx="3">
-            <a:schemeClr val="accent1"/>
-          </a:fillRef>
-          <a:effectRef idx="2">
-            <a:schemeClr val="accent1"/>
-          </a:effectRef>
-          <a:fontRef idx="minor">
-            <a:schemeClr val="lt1"/>
-          </a:fontRef>
-        </p:style>
-        <p:txBody>
-          <a:bodyPr rtlCol="0" anchor="ctr" wrap="square"/>
-          <a:lstStyle/>
-          <a:p>
-            <a:pPr algn="ctr"/>
-          </a:p>
-        </p:txBody>
-      </p:sp>
-      <p:sp>
-        <p:nvSpPr>
-          <p:cNvPr id="14" name="TextBox 13"/>
-          <p:cNvSpPr txBox="1"/>
-          <p:nvPr/>
-        </p:nvSpPr>
-        <p:spPr>
-          <a:xfrm>
             <a:off x="640080" y="6437376"/>
             <a:ext cx="1240440" cy="152146"/>
           </a:xfrm>
@@ -13611,7 +13513,7 @@
       </p:sp>
       <p:sp>
         <p:nvSpPr>
-          <p:cNvPr id="15" name="Oval 14"/>
+          <p:cNvPr id="13" name="Oval 12"/>
           <p:cNvSpPr/>
           <p:nvPr/>
         </p:nvSpPr>
@@ -13655,7 +13557,7 @@
       </p:sp>
       <p:sp>
         <p:nvSpPr>
-          <p:cNvPr id="16" name="TextBox 15"/>
+          <p:cNvPr id="14" name="TextBox 13"/>
           <p:cNvSpPr txBox="1"/>
           <p:nvPr/>
         </p:nvSpPr>
@@ -13690,7 +13592,7 @@
       </p:sp>
       <p:sp>
         <p:nvSpPr>
-          <p:cNvPr id="17" name="Oval 16"/>
+          <p:cNvPr id="15" name="Oval 14"/>
           <p:cNvSpPr/>
           <p:nvPr/>
         </p:nvSpPr>
@@ -13734,7 +13636,7 @@
       </p:sp>
       <p:sp>
         <p:nvSpPr>
-          <p:cNvPr id="18" name="TextBox 17"/>
+          <p:cNvPr id="16" name="TextBox 15"/>
           <p:cNvSpPr txBox="1"/>
           <p:nvPr/>
         </p:nvSpPr>
@@ -13769,7 +13671,7 @@
       </p:sp>
       <p:sp>
         <p:nvSpPr>
-          <p:cNvPr id="19" name="Oval 18"/>
+          <p:cNvPr id="17" name="Oval 16"/>
           <p:cNvSpPr/>
           <p:nvPr/>
         </p:nvSpPr>
@@ -13813,7 +13715,7 @@
       </p:sp>
       <p:sp>
         <p:nvSpPr>
-          <p:cNvPr id="20" name="TextBox 19"/>
+          <p:cNvPr id="18" name="TextBox 17"/>
           <p:cNvSpPr txBox="1"/>
           <p:nvPr/>
         </p:nvSpPr>
@@ -13848,7 +13750,7 @@
       </p:sp>
       <p:sp>
         <p:nvSpPr>
-          <p:cNvPr id="21" name="Oval 20"/>
+          <p:cNvPr id="19" name="Oval 18"/>
           <p:cNvSpPr/>
           <p:nvPr/>
         </p:nvSpPr>
@@ -13892,7 +13794,7 @@
       </p:sp>
       <p:sp>
         <p:nvSpPr>
-          <p:cNvPr id="22" name="TextBox 21"/>
+          <p:cNvPr id="20" name="TextBox 19"/>
           <p:cNvSpPr txBox="1"/>
           <p:nvPr/>
         </p:nvSpPr>
@@ -13927,7 +13829,7 @@
       </p:sp>
       <p:sp>
         <p:nvSpPr>
-          <p:cNvPr id="23" name="Oval 22"/>
+          <p:cNvPr id="21" name="Oval 20"/>
           <p:cNvSpPr/>
           <p:nvPr/>
         </p:nvSpPr>
@@ -13971,7 +13873,7 @@
       </p:sp>
       <p:sp>
         <p:nvSpPr>
-          <p:cNvPr id="24" name="TextBox 23"/>
+          <p:cNvPr id="22" name="TextBox 21"/>
           <p:cNvSpPr txBox="1"/>
           <p:nvPr/>
         </p:nvSpPr>
@@ -14006,7 +13908,7 @@
       </p:sp>
       <p:sp>
         <p:nvSpPr>
-          <p:cNvPr id="25" name="TextBox 24"/>
+          <p:cNvPr id="23" name="TextBox 22"/>
           <p:cNvSpPr txBox="1"/>
           <p:nvPr/>
         </p:nvSpPr>
@@ -15193,7 +15095,7 @@
       </p:sp>
       <p:pic>
         <p:nvPicPr>
-          <p:cNvPr id="9" name="mermaid diagram" descr="103ced1a8663a069.png"/>
+          <p:cNvPr id="9" name="mermaid diagram" descr="b0276012dc0e6dba.png"/>
           <p:cNvPicPr>
             <a:picLocks noChangeAspect="1"/>
           </p:cNvPicPr>
@@ -15207,8 +15109,8 @@
         </p:blipFill>
         <p:spPr>
           <a:xfrm>
-            <a:off x="982979" y="1682496"/>
-            <a:ext cx="3881071" cy="4517136"/>
+            <a:off x="806107" y="1682496"/>
+            <a:ext cx="4234815" cy="4517136"/>
           </a:xfrm>
           <a:prstGeom prst="rect">
             <a:avLst/>
@@ -16175,8 +16077,8 @@
                 <a:tableStyleId>{2D5ABB26-0587-4C30-8999-92F81FD0307C}</a:tableStyleId>
               </a:tblPr>
               <a:tblGrid>
-                <a:gridCol w="4320700"/>
-                <a:gridCol w="6810290"/>
+                <a:gridCol w="3847412"/>
+                <a:gridCol w="7283578"/>
               </a:tblGrid>
               <a:tr h="310896">
                 <a:tc>
@@ -16375,7 +16277,7 @@
                           </a:solidFill>
                           <a:latin typeface="Calibri"/>
                         </a:rPr>
-                        <a:t>4. Was it the season?</a:t>
+                        <a:t>4. A season for everyone?</a:t>
                       </a:r>
                     </a:p>
                   </a:txBody>
@@ -16397,7 +16299,7 @@
                           </a:solidFill>
                           <a:latin typeface="Calibri"/>
                         </a:rPr>
-                        <a:t>No: Retail-Core kept 95 percent of its orders</a:t>
+                        <a:t>No: Retail-Core kept 95 percent; a members-only dip stays open</a:t>
                       </a:r>
                     </a:p>
                   </a:txBody>
@@ -16690,7 +16592,7 @@
                 </a:solidFill>
                 <a:latin typeface="Calibri"/>
               </a:rPr>
-              <a:t>"You gave the tier a number for his cause, a ceiling of about 4 orders, and named the data that would settle it. Say what you know, then what you are guessing, and stop."</a:t>
+              <a:t>"You gave the tier's head a number for his cause, a ceiling of about 4 orders, and named the data that would settle it. Say what you know, then what you are guessing, and stop."</a:t>
             </a:r>
           </a:p>
         </p:txBody>
@@ -18817,7 +18719,46 @@
       </p:graphicFrame>
       <p:sp>
         <p:nvSpPr>
-          <p:cNvPr id="10" name="Oval 9"/>
+          <p:cNvPr id="10" name="TextBox 9"/>
+          <p:cNvSpPr txBox="1"/>
+          <p:nvPr/>
+        </p:nvSpPr>
+        <p:spPr>
+          <a:xfrm>
+            <a:off x="530352" y="4801616"/>
+            <a:ext cx="11130991" cy="495807"/>
+          </a:xfrm>
+          <a:prstGeom prst="rect">
+            <a:avLst/>
+          </a:prstGeom>
+          <a:noFill/>
+        </p:spPr>
+        <p:txBody>
+          <a:bodyPr wrap="square" anchor="t" lIns="0" rIns="0" tIns="0" bIns="0">
+            <a:spAutoFit/>
+          </a:bodyPr>
+          <a:lstStyle/>
+          <a:p>
+            <a:pPr>
+              <a:spcAft>
+                <a:spcPts val="800"/>
+              </a:spcAft>
+            </a:pPr>
+            <a:r>
+              <a:rPr sz="1600" b="0" i="0">
+                <a:solidFill>
+                  <a:srgbClr val="1A1440"/>
+                </a:solidFill>
+                <a:latin typeface="Calibri"/>
+              </a:rPr>
+              <a:t>Kavya Nair, the team's senior analyst, reviews every chapter's answer before it reaches Meera.</a:t>
+            </a:r>
+          </a:p>
+        </p:txBody>
+      </p:sp>
+      <p:sp>
+        <p:nvSpPr>
+          <p:cNvPr id="11" name="Oval 10"/>
           <p:cNvSpPr/>
           <p:nvPr/>
         </p:nvSpPr>
@@ -18861,7 +18802,7 @@
       </p:sp>
       <p:sp>
         <p:nvSpPr>
-          <p:cNvPr id="11" name="TextBox 10"/>
+          <p:cNvPr id="12" name="TextBox 11"/>
           <p:cNvSpPr txBox="1"/>
           <p:nvPr/>
         </p:nvSpPr>
@@ -18896,7 +18837,7 @@
       </p:sp>
       <p:sp>
         <p:nvSpPr>
-          <p:cNvPr id="12" name="Oval 11"/>
+          <p:cNvPr id="13" name="Oval 12"/>
           <p:cNvSpPr/>
           <p:nvPr/>
         </p:nvSpPr>
@@ -18940,7 +18881,7 @@
       </p:sp>
       <p:sp>
         <p:nvSpPr>
-          <p:cNvPr id="13" name="TextBox 12"/>
+          <p:cNvPr id="14" name="TextBox 13"/>
           <p:cNvSpPr txBox="1"/>
           <p:nvPr/>
         </p:nvSpPr>
@@ -18975,7 +18916,7 @@
       </p:sp>
       <p:sp>
         <p:nvSpPr>
-          <p:cNvPr id="14" name="Oval 13"/>
+          <p:cNvPr id="15" name="Oval 14"/>
           <p:cNvSpPr/>
           <p:nvPr/>
         </p:nvSpPr>
@@ -19019,7 +18960,7 @@
       </p:sp>
       <p:sp>
         <p:nvSpPr>
-          <p:cNvPr id="15" name="TextBox 14"/>
+          <p:cNvPr id="16" name="TextBox 15"/>
           <p:cNvSpPr txBox="1"/>
           <p:nvPr/>
         </p:nvSpPr>
@@ -19054,7 +18995,7 @@
       </p:sp>
       <p:sp>
         <p:nvSpPr>
-          <p:cNvPr id="16" name="Oval 15"/>
+          <p:cNvPr id="17" name="Oval 16"/>
           <p:cNvSpPr/>
           <p:nvPr/>
         </p:nvSpPr>
@@ -19098,7 +19039,7 @@
       </p:sp>
       <p:sp>
         <p:nvSpPr>
-          <p:cNvPr id="17" name="TextBox 16"/>
+          <p:cNvPr id="18" name="TextBox 17"/>
           <p:cNvSpPr txBox="1"/>
           <p:nvPr/>
         </p:nvSpPr>
@@ -19133,7 +19074,7 @@
       </p:sp>
       <p:sp>
         <p:nvSpPr>
-          <p:cNvPr id="18" name="Oval 17"/>
+          <p:cNvPr id="19" name="Oval 18"/>
           <p:cNvSpPr/>
           <p:nvPr/>
         </p:nvSpPr>
@@ -19177,7 +19118,7 @@
       </p:sp>
       <p:sp>
         <p:nvSpPr>
-          <p:cNvPr id="19" name="TextBox 18"/>
+          <p:cNvPr id="20" name="TextBox 19"/>
           <p:cNvSpPr txBox="1"/>
           <p:nvPr/>
         </p:nvSpPr>
@@ -19212,7 +19153,7 @@
       </p:sp>
       <p:sp>
         <p:nvSpPr>
-          <p:cNvPr id="20" name="Oval 19"/>
+          <p:cNvPr id="21" name="Oval 20"/>
           <p:cNvSpPr/>
           <p:nvPr/>
         </p:nvSpPr>
@@ -19256,7 +19197,7 @@
       </p:sp>
       <p:sp>
         <p:nvSpPr>
-          <p:cNvPr id="21" name="TextBox 20"/>
+          <p:cNvPr id="22" name="TextBox 21"/>
           <p:cNvSpPr txBox="1"/>
           <p:nvPr/>
         </p:nvSpPr>
@@ -19291,7 +19232,7 @@
       </p:sp>
       <p:sp>
         <p:nvSpPr>
-          <p:cNvPr id="22" name="TextBox 21"/>
+          <p:cNvPr id="23" name="TextBox 22"/>
           <p:cNvSpPr txBox="1"/>
           <p:nvPr/>
         </p:nvSpPr>
@@ -21537,7 +21478,7 @@
                 </a:solidFill>
                 <a:latin typeface="Georgia"/>
               </a:rPr>
-              <a:t>Seven lettered choices, each checked, one sentence</a:t>
+              <a:t>You hand in seven checked picks and one sentence</a:t>
             </a:r>
           </a:p>
         </p:txBody>
@@ -23643,7 +23584,7 @@
       </p:sp>
       <p:pic>
         <p:nvPicPr>
-          <p:cNvPr id="9" name="mermaid diagram" descr="988852f7771066ef.png"/>
+          <p:cNvPr id="9" name="mermaid diagram" descr="2b7b75c1b6faf68c.png"/>
           <p:cNvPicPr>
             <a:picLocks noChangeAspect="1"/>
           </p:cNvPicPr>
@@ -23657,8 +23598,8 @@
         </p:blipFill>
         <p:spPr>
           <a:xfrm>
-            <a:off x="1243588" y="1682496"/>
-            <a:ext cx="3359853" cy="4517136"/>
+            <a:off x="1215354" y="1682496"/>
+            <a:ext cx="3416321" cy="4517136"/>
           </a:xfrm>
           <a:prstGeom prst="rect">
             <a:avLst/>
@@ -24601,7 +24542,7 @@
                 </a:solidFill>
                 <a:latin typeface="Calibri"/>
               </a:rPr>
-              <a:t>Did delivered customers really fall from 54 to 50?</a:t>
+              <a:t>What does the room conclude from 54 to 50 delivered customers?</a:t>
             </a:r>
           </a:p>
         </p:txBody>
@@ -25512,14 +25453,14 @@
                 </a:solidFill>
                 <a:latin typeface="Calibri"/>
               </a:rPr>
-              <a:t>How far did delivered orders per customer fall, weighted by customers?</a:t>
+              <a:t>How far did delivered frequency fall if the four segments' rates are averaged?</a:t>
             </a:r>
           </a:p>
         </p:txBody>
       </p:sp>
       <p:pic>
         <p:nvPicPr>
-          <p:cNvPr id="9" name="mermaid diagram" descr="4a03608887a649cb.png"/>
+          <p:cNvPr id="9" name="mermaid diagram" descr="917f2adde613ba0e.png"/>
           <p:cNvPicPr>
             <a:picLocks noChangeAspect="1"/>
           </p:cNvPicPr>
@@ -26423,7 +26364,7 @@
                 </a:solidFill>
                 <a:latin typeface="Calibri"/>
               </a:rPr>
-              <a:t>Does a smaller mix share on delivered orders mean prices rose?</a:t>
+              <a:t>What does the room conclude from a 44 percent mix share on delivered orders?</a:t>
             </a:r>
           </a:p>
         </p:txBody>
@@ -27629,8 +27570,8 @@
         </p:blipFill>
         <p:spPr>
           <a:xfrm>
-            <a:off x="3607649" y="1664208"/>
-            <a:ext cx="4976396" cy="2944368"/>
+            <a:off x="3826590" y="1664208"/>
+            <a:ext cx="4538514" cy="2685288"/>
           </a:xfrm>
           <a:prstGeom prst="rect">
             <a:avLst/>
@@ -27645,8 +27586,8 @@
         </p:nvSpPr>
         <p:spPr>
           <a:xfrm>
-            <a:off x="530352" y="4654296"/>
-            <a:ext cx="11130991" cy="1380744"/>
+            <a:off x="530352" y="4395216"/>
+            <a:ext cx="11130991" cy="1639824"/>
           </a:xfrm>
           <a:prstGeom prst="roundRect">
             <a:avLst>
@@ -27699,7 +27640,7 @@
         </p:nvSpPr>
         <p:spPr>
           <a:xfrm>
-            <a:off x="758952" y="5116068"/>
+            <a:off x="758952" y="4986528"/>
             <a:ext cx="457200" cy="457200"/>
           </a:xfrm>
           <a:prstGeom prst="ellipse">
@@ -27751,7 +27692,7 @@
         </p:blipFill>
         <p:spPr>
           <a:xfrm>
-            <a:off x="868680" y="5225796"/>
+            <a:off x="868680" y="5096256"/>
             <a:ext cx="237744" cy="237744"/>
           </a:xfrm>
           <a:prstGeom prst="rect">
@@ -27767,7 +27708,7 @@
         </p:nvSpPr>
         <p:spPr>
           <a:xfrm>
-            <a:off x="1399031" y="4800600"/>
+            <a:off x="1399031" y="4541520"/>
             <a:ext cx="9987991" cy="160401"/>
           </a:xfrm>
           <a:prstGeom prst="rect">
@@ -27802,8 +27743,8 @@
         </p:nvSpPr>
         <p:spPr>
           <a:xfrm>
-            <a:off x="1399031" y="5020056"/>
-            <a:ext cx="9987991" cy="941832"/>
+            <a:off x="1399031" y="4760976"/>
+            <a:ext cx="9987991" cy="1200912"/>
           </a:xfrm>
           <a:prstGeom prst="rect">
             <a:avLst/>
@@ -27823,7 +27764,7 @@
                 </a:solidFill>
                 <a:latin typeface="Calibri"/>
               </a:rPr>
-              <a:t>"On delivered orders the story held: frequency, Retail-Plus at minus 42.6 percent per member, and the same two hypotheses. The branch that moved was fulfilment, getting orders to customers intact. Put the definition beside every number, and the solution is open now."</a:t>
+              <a:t>"On delivered orders the story held: frequency carries the most rupees, Retail-Plus falls 42.6 percent per member, and the same two hypotheses stand. The customers branch that moved there is cancellations and returns, to be split by reason. Put the definition beside every number; the solution is open now."</a:t>
             </a:r>
           </a:p>
         </p:txBody>
@@ -31706,7 +31647,7 @@
                           </a:solidFill>
                           <a:latin typeface="Calibri"/>
                         </a:rPr>
-                        <a:t>Tier revenue fell about 45 percent; one leaf that rose is not the tier</a:t>
+                        <a:t>Tier revenue still fell about 45 percent, whatever one leaf did</a:t>
                       </a:r>
                     </a:p>
                   </a:txBody>
@@ -31859,27 +31800,62 @@
       </p:graphicFrame>
       <p:sp>
         <p:nvSpPr>
-          <p:cNvPr id="10" name="Rounded Rectangle 9"/>
+          <p:cNvPr id="10" name="TextBox 9"/>
+          <p:cNvSpPr txBox="1"/>
+          <p:nvPr/>
+        </p:nvSpPr>
+        <p:spPr>
+          <a:xfrm>
+            <a:off x="530352" y="4175760"/>
+            <a:ext cx="11130991" cy="772160"/>
+          </a:xfrm>
+          <a:prstGeom prst="rect">
+            <a:avLst/>
+          </a:prstGeom>
+          <a:noFill/>
+        </p:spPr>
+        <p:txBody>
+          <a:bodyPr wrap="square" anchor="t" lIns="0" rIns="0" tIns="0" bIns="0">
+            <a:spAutoFit/>
+          </a:bodyPr>
+          <a:lstStyle/>
+          <a:p>
+            <a:pPr>
+              <a:spcAft>
+                <a:spcPts val="800"/>
+              </a:spcAft>
+            </a:pPr>
+            <a:r>
+              <a:rPr sz="1600" b="0" i="0">
+                <a:solidFill>
+                  <a:srgbClr val="1A1440"/>
+                </a:solidFill>
+                <a:latin typeface="Calibri"/>
+              </a:rPr>
+              <a:t>The one request that tests the most is the tier's July change log, renewals and support tickets, since the fall began in July; the reorder logs come second.</a:t>
+            </a:r>
+          </a:p>
+        </p:txBody>
+      </p:sp>
+      <p:sp>
+        <p:nvSpPr>
+          <p:cNvPr id="11" name="Oval 10"/>
           <p:cNvSpPr/>
           <p:nvPr/>
         </p:nvSpPr>
         <p:spPr>
           <a:xfrm>
-            <a:off x="530352" y="4175760"/>
-            <a:ext cx="11130991" cy="807720"/>
-          </a:xfrm>
-          <a:prstGeom prst="roundRect">
-            <a:avLst>
-              <a:gd name="adj" fmla="val 8000"/>
-            </a:avLst>
+            <a:off x="530352" y="6492240"/>
+            <a:ext cx="64008" cy="64008"/>
+          </a:xfrm>
+          <a:prstGeom prst="ellipse">
+            <a:avLst/>
           </a:prstGeom>
           <a:solidFill>
-            <a:srgbClr val="F7F5FD"/>
+            <a:srgbClr val="CFC9EE"/>
           </a:solidFill>
-          <a:ln w="9525">
-            <a:solidFill>
-              <a:srgbClr val="E4E1F1"/>
-            </a:solidFill>
+          <a:ln>
+            <a:noFill/>
           </a:ln>
           <a:effectLst/>
         </p:spPr>
@@ -31907,19 +31883,210 @@
       </p:sp>
       <p:sp>
         <p:nvSpPr>
-          <p:cNvPr id="11" name="Rounded Rectangle 10"/>
+          <p:cNvPr id="12" name="TextBox 11"/>
+          <p:cNvSpPr txBox="1"/>
+          <p:nvPr/>
+        </p:nvSpPr>
+        <p:spPr>
+          <a:xfrm>
+            <a:off x="640080" y="6437376"/>
+            <a:ext cx="1240440" cy="152146"/>
+          </a:xfrm>
+          <a:prstGeom prst="rect">
+            <a:avLst/>
+          </a:prstGeom>
+          <a:noFill/>
+        </p:spPr>
+        <p:txBody>
+          <a:bodyPr wrap="square" anchor="t" lIns="0" rIns="0" tIns="0" bIns="0">
+            <a:spAutoFit/>
+          </a:bodyPr>
+          <a:lstStyle/>
+          <a:p>
+            <a:pPr algn="l"/>
+            <a:r>
+              <a:rPr sz="700" b="0" i="0">
+                <a:solidFill>
+                  <a:srgbClr val="6B6690"/>
+                </a:solidFill>
+                <a:latin typeface="Calibri"/>
+              </a:rPr>
+              <a:t>Did the button do it?</a:t>
+            </a:r>
+          </a:p>
+        </p:txBody>
+      </p:sp>
+      <p:sp>
+        <p:nvSpPr>
+          <p:cNvPr id="13" name="Oval 12"/>
           <p:cNvSpPr/>
           <p:nvPr/>
         </p:nvSpPr>
         <p:spPr>
           <a:xfrm>
-            <a:off x="676656" y="4303775"/>
-            <a:ext cx="45720" cy="551688"/>
-          </a:xfrm>
-          <a:prstGeom prst="roundRect">
-            <a:avLst>
-              <a:gd name="adj" fmla="val 50000"/>
-            </a:avLst>
+            <a:off x="1971960" y="6492240"/>
+            <a:ext cx="64008" cy="64008"/>
+          </a:xfrm>
+          <a:prstGeom prst="ellipse">
+            <a:avLst/>
+          </a:prstGeom>
+          <a:solidFill>
+            <a:srgbClr val="CFC9EE"/>
+          </a:solidFill>
+          <a:ln>
+            <a:noFill/>
+          </a:ln>
+          <a:effectLst/>
+        </p:spPr>
+        <p:style>
+          <a:lnRef idx="1">
+            <a:schemeClr val="accent1"/>
+          </a:lnRef>
+          <a:fillRef idx="3">
+            <a:schemeClr val="accent1"/>
+          </a:fillRef>
+          <a:effectRef idx="2">
+            <a:schemeClr val="accent1"/>
+          </a:effectRef>
+          <a:fontRef idx="minor">
+            <a:schemeClr val="lt1"/>
+          </a:fontRef>
+        </p:style>
+        <p:txBody>
+          <a:bodyPr rtlCol="0" anchor="ctr" wrap="square"/>
+          <a:lstStyle/>
+          <a:p>
+            <a:pPr algn="ctr"/>
+          </a:p>
+        </p:txBody>
+      </p:sp>
+      <p:sp>
+        <p:nvSpPr>
+          <p:cNvPr id="14" name="TextBox 13"/>
+          <p:cNvSpPr txBox="1"/>
+          <p:nvPr/>
+        </p:nvSpPr>
+        <p:spPr>
+          <a:xfrm>
+            <a:off x="2081688" y="6437376"/>
+            <a:ext cx="1424463" cy="152146"/>
+          </a:xfrm>
+          <a:prstGeom prst="rect">
+            <a:avLst/>
+          </a:prstGeom>
+          <a:noFill/>
+        </p:spPr>
+        <p:txBody>
+          <a:bodyPr wrap="square" anchor="t" lIns="0" rIns="0" tIns="0" bIns="0">
+            <a:spAutoFit/>
+          </a:bodyPr>
+          <a:lstStyle/>
+          <a:p>
+            <a:pPr algn="l"/>
+            <a:r>
+              <a:rPr sz="700" b="0" i="0">
+                <a:solidFill>
+                  <a:srgbClr val="6B6690"/>
+                </a:solidFill>
+                <a:latin typeface="Calibri"/>
+              </a:rPr>
+              <a:t>Does it survive delivery?</a:t>
+            </a:r>
+          </a:p>
+        </p:txBody>
+      </p:sp>
+      <p:sp>
+        <p:nvSpPr>
+          <p:cNvPr id="15" name="Oval 14"/>
+          <p:cNvSpPr/>
+          <p:nvPr/>
+        </p:nvSpPr>
+        <p:spPr>
+          <a:xfrm>
+            <a:off x="3597592" y="6492240"/>
+            <a:ext cx="64008" cy="64008"/>
+          </a:xfrm>
+          <a:prstGeom prst="ellipse">
+            <a:avLst/>
+          </a:prstGeom>
+          <a:solidFill>
+            <a:srgbClr val="CFC9EE"/>
+          </a:solidFill>
+          <a:ln>
+            <a:noFill/>
+          </a:ln>
+          <a:effectLst/>
+        </p:spPr>
+        <p:style>
+          <a:lnRef idx="1">
+            <a:schemeClr val="accent1"/>
+          </a:lnRef>
+          <a:fillRef idx="3">
+            <a:schemeClr val="accent1"/>
+          </a:fillRef>
+          <a:effectRef idx="2">
+            <a:schemeClr val="accent1"/>
+          </a:effectRef>
+          <a:fontRef idx="minor">
+            <a:schemeClr val="lt1"/>
+          </a:fontRef>
+        </p:style>
+        <p:txBody>
+          <a:bodyPr rtlCol="0" anchor="ctr" wrap="square"/>
+          <a:lstStyle/>
+          <a:p>
+            <a:pPr algn="ctr"/>
+          </a:p>
+        </p:txBody>
+      </p:sp>
+      <p:sp>
+        <p:nvSpPr>
+          <p:cNvPr id="16" name="TextBox 15"/>
+          <p:cNvSpPr txBox="1"/>
+          <p:nvPr/>
+        </p:nvSpPr>
+        <p:spPr>
+          <a:xfrm>
+            <a:off x="3707320" y="6437376"/>
+            <a:ext cx="1286446" cy="152146"/>
+          </a:xfrm>
+          <a:prstGeom prst="rect">
+            <a:avLst/>
+          </a:prstGeom>
+          <a:noFill/>
+        </p:spPr>
+        <p:txBody>
+          <a:bodyPr wrap="square" anchor="t" lIns="0" rIns="0" tIns="0" bIns="0">
+            <a:spAutoFit/>
+          </a:bodyPr>
+          <a:lstStyle/>
+          <a:p>
+            <a:pPr algn="l"/>
+            <a:r>
+              <a:rPr sz="700" b="0" i="0">
+                <a:solidFill>
+                  <a:srgbClr val="6B6690"/>
+                </a:solidFill>
+                <a:latin typeface="Calibri"/>
+              </a:rPr>
+              <a:t>Where did we go wrong?</a:t>
+            </a:r>
+          </a:p>
+        </p:txBody>
+      </p:sp>
+      <p:sp>
+        <p:nvSpPr>
+          <p:cNvPr id="17" name="Oval 16"/>
+          <p:cNvSpPr/>
+          <p:nvPr/>
+        </p:nvSpPr>
+        <p:spPr>
+          <a:xfrm>
+            <a:off x="5085206" y="6492240"/>
+            <a:ext cx="64008" cy="64008"/>
+          </a:xfrm>
+          <a:prstGeom prst="ellipse">
+            <a:avLst/>
           </a:prstGeom>
           <a:solidFill>
             <a:srgbClr val="5B3FD6"/>
@@ -31953,56 +32120,48 @@
       </p:sp>
       <p:sp>
         <p:nvSpPr>
-          <p:cNvPr id="12" name="TextBox 11"/>
-          <p:cNvSpPr txBox="1"/>
-          <p:nvPr/>
-        </p:nvSpPr>
-        <p:spPr>
-          <a:xfrm>
-            <a:off x="877824" y="4294632"/>
-            <a:ext cx="10564063" cy="624840"/>
-          </a:xfrm>
-          <a:prstGeom prst="rect">
-            <a:avLst/>
-          </a:prstGeom>
-          <a:noFill/>
-        </p:spPr>
-        <p:txBody>
-          <a:bodyPr wrap="square" anchor="ctr" lIns="0" rIns="0" tIns="0" bIns="0">
-            <a:spAutoFit/>
-          </a:bodyPr>
-          <a:lstStyle/>
-          <a:p>
-            <a:r>
-              <a:rPr sz="1500" b="1">
+          <p:cNvPr id="18" name="TextBox 17"/>
+          <p:cNvSpPr txBox="1"/>
+          <p:nvPr/>
+        </p:nvSpPr>
+        <p:spPr>
+          <a:xfrm>
+            <a:off x="5194934" y="6437376"/>
+            <a:ext cx="1194435" cy="152146"/>
+          </a:xfrm>
+          <a:prstGeom prst="rect">
+            <a:avLst/>
+          </a:prstGeom>
+          <a:noFill/>
+        </p:spPr>
+        <p:txBody>
+          <a:bodyPr wrap="square" anchor="t" lIns="0" rIns="0" tIns="0" bIns="0">
+            <a:spAutoFit/>
+          </a:bodyPr>
+          <a:lstStyle/>
+          <a:p>
+            <a:pPr algn="l"/>
+            <a:r>
+              <a:rPr sz="700" b="1" i="0">
                 <a:solidFill>
                   <a:srgbClr val="5B3FD6"/>
                 </a:solidFill>
                 <a:latin typeface="Calibri"/>
               </a:rPr>
-              <a:t>The one request. </a:t>
-            </a:r>
-            <a:r>
-              <a:rPr sz="1500" b="0" i="0">
-                <a:solidFill>
-                  <a:srgbClr val="1A1440"/>
-                </a:solidFill>
-                <a:latin typeface="Calibri"/>
-              </a:rPr>
-              <a:t>The tier's July change log, renewals and support tickets, since the fall began in July; the reorder logs second.</a:t>
-            </a:r>
-          </a:p>
-        </p:txBody>
-      </p:sp>
-      <p:sp>
-        <p:nvSpPr>
-          <p:cNvPr id="13" name="Oval 12"/>
+              <a:t>Is the tier healthy?</a:t>
+            </a:r>
+          </a:p>
+        </p:txBody>
+      </p:sp>
+      <p:sp>
+        <p:nvSpPr>
+          <p:cNvPr id="19" name="Oval 18"/>
           <p:cNvSpPr/>
           <p:nvPr/>
         </p:nvSpPr>
         <p:spPr>
           <a:xfrm>
-            <a:off x="530352" y="6492240"/>
+            <a:off x="6480809" y="6492240"/>
             <a:ext cx="64008" cy="64008"/>
           </a:xfrm>
           <a:prstGeom prst="ellipse">
@@ -32040,13 +32199,13 @@
       </p:sp>
       <p:sp>
         <p:nvSpPr>
-          <p:cNvPr id="14" name="TextBox 13"/>
-          <p:cNvSpPr txBox="1"/>
-          <p:nvPr/>
-        </p:nvSpPr>
-        <p:spPr>
-          <a:xfrm>
-            <a:off x="640080" y="6437376"/>
+          <p:cNvPr id="20" name="TextBox 19"/>
+          <p:cNvSpPr txBox="1"/>
+          <p:nvPr/>
+        </p:nvSpPr>
+        <p:spPr>
+          <a:xfrm>
+            <a:off x="6590538" y="6437376"/>
             <a:ext cx="1240440" cy="152146"/>
           </a:xfrm>
           <a:prstGeom prst="rect">
@@ -32068,20 +32227,20 @@
                 </a:solidFill>
                 <a:latin typeface="Calibri"/>
               </a:rPr>
-              <a:t>Did the button do it?</a:t>
-            </a:r>
-          </a:p>
-        </p:txBody>
-      </p:sp>
-      <p:sp>
-        <p:nvSpPr>
-          <p:cNvPr id="15" name="Oval 14"/>
+              <a:t>Can you say it aloud?</a:t>
+            </a:r>
+          </a:p>
+        </p:txBody>
+      </p:sp>
+      <p:sp>
+        <p:nvSpPr>
+          <p:cNvPr id="21" name="Oval 20"/>
           <p:cNvSpPr/>
           <p:nvPr/>
         </p:nvSpPr>
         <p:spPr>
           <a:xfrm>
-            <a:off x="1971960" y="6492240"/>
+            <a:off x="7922418" y="6492240"/>
             <a:ext cx="64008" cy="64008"/>
           </a:xfrm>
           <a:prstGeom prst="ellipse">
@@ -32119,323 +32278,7 @@
       </p:sp>
       <p:sp>
         <p:nvSpPr>
-          <p:cNvPr id="16" name="TextBox 15"/>
-          <p:cNvSpPr txBox="1"/>
-          <p:nvPr/>
-        </p:nvSpPr>
-        <p:spPr>
-          <a:xfrm>
-            <a:off x="2081688" y="6437376"/>
-            <a:ext cx="1424463" cy="152146"/>
-          </a:xfrm>
-          <a:prstGeom prst="rect">
-            <a:avLst/>
-          </a:prstGeom>
-          <a:noFill/>
-        </p:spPr>
-        <p:txBody>
-          <a:bodyPr wrap="square" anchor="t" lIns="0" rIns="0" tIns="0" bIns="0">
-            <a:spAutoFit/>
-          </a:bodyPr>
-          <a:lstStyle/>
-          <a:p>
-            <a:pPr algn="l"/>
-            <a:r>
-              <a:rPr sz="700" b="0" i="0">
-                <a:solidFill>
-                  <a:srgbClr val="6B6690"/>
-                </a:solidFill>
-                <a:latin typeface="Calibri"/>
-              </a:rPr>
-              <a:t>Does it survive delivery?</a:t>
-            </a:r>
-          </a:p>
-        </p:txBody>
-      </p:sp>
-      <p:sp>
-        <p:nvSpPr>
-          <p:cNvPr id="17" name="Oval 16"/>
-          <p:cNvSpPr/>
-          <p:nvPr/>
-        </p:nvSpPr>
-        <p:spPr>
-          <a:xfrm>
-            <a:off x="3597592" y="6492240"/>
-            <a:ext cx="64008" cy="64008"/>
-          </a:xfrm>
-          <a:prstGeom prst="ellipse">
-            <a:avLst/>
-          </a:prstGeom>
-          <a:solidFill>
-            <a:srgbClr val="CFC9EE"/>
-          </a:solidFill>
-          <a:ln>
-            <a:noFill/>
-          </a:ln>
-          <a:effectLst/>
-        </p:spPr>
-        <p:style>
-          <a:lnRef idx="1">
-            <a:schemeClr val="accent1"/>
-          </a:lnRef>
-          <a:fillRef idx="3">
-            <a:schemeClr val="accent1"/>
-          </a:fillRef>
-          <a:effectRef idx="2">
-            <a:schemeClr val="accent1"/>
-          </a:effectRef>
-          <a:fontRef idx="minor">
-            <a:schemeClr val="lt1"/>
-          </a:fontRef>
-        </p:style>
-        <p:txBody>
-          <a:bodyPr rtlCol="0" anchor="ctr" wrap="square"/>
-          <a:lstStyle/>
-          <a:p>
-            <a:pPr algn="ctr"/>
-          </a:p>
-        </p:txBody>
-      </p:sp>
-      <p:sp>
-        <p:nvSpPr>
-          <p:cNvPr id="18" name="TextBox 17"/>
-          <p:cNvSpPr txBox="1"/>
-          <p:nvPr/>
-        </p:nvSpPr>
-        <p:spPr>
-          <a:xfrm>
-            <a:off x="3707320" y="6437376"/>
-            <a:ext cx="1286446" cy="152146"/>
-          </a:xfrm>
-          <a:prstGeom prst="rect">
-            <a:avLst/>
-          </a:prstGeom>
-          <a:noFill/>
-        </p:spPr>
-        <p:txBody>
-          <a:bodyPr wrap="square" anchor="t" lIns="0" rIns="0" tIns="0" bIns="0">
-            <a:spAutoFit/>
-          </a:bodyPr>
-          <a:lstStyle/>
-          <a:p>
-            <a:pPr algn="l"/>
-            <a:r>
-              <a:rPr sz="700" b="0" i="0">
-                <a:solidFill>
-                  <a:srgbClr val="6B6690"/>
-                </a:solidFill>
-                <a:latin typeface="Calibri"/>
-              </a:rPr>
-              <a:t>Where did we go wrong?</a:t>
-            </a:r>
-          </a:p>
-        </p:txBody>
-      </p:sp>
-      <p:sp>
-        <p:nvSpPr>
-          <p:cNvPr id="19" name="Oval 18"/>
-          <p:cNvSpPr/>
-          <p:nvPr/>
-        </p:nvSpPr>
-        <p:spPr>
-          <a:xfrm>
-            <a:off x="5085206" y="6492240"/>
-            <a:ext cx="64008" cy="64008"/>
-          </a:xfrm>
-          <a:prstGeom prst="ellipse">
-            <a:avLst/>
-          </a:prstGeom>
-          <a:solidFill>
-            <a:srgbClr val="5B3FD6"/>
-          </a:solidFill>
-          <a:ln>
-            <a:noFill/>
-          </a:ln>
-          <a:effectLst/>
-        </p:spPr>
-        <p:style>
-          <a:lnRef idx="1">
-            <a:schemeClr val="accent1"/>
-          </a:lnRef>
-          <a:fillRef idx="3">
-            <a:schemeClr val="accent1"/>
-          </a:fillRef>
-          <a:effectRef idx="2">
-            <a:schemeClr val="accent1"/>
-          </a:effectRef>
-          <a:fontRef idx="minor">
-            <a:schemeClr val="lt1"/>
-          </a:fontRef>
-        </p:style>
-        <p:txBody>
-          <a:bodyPr rtlCol="0" anchor="ctr" wrap="square"/>
-          <a:lstStyle/>
-          <a:p>
-            <a:pPr algn="ctr"/>
-          </a:p>
-        </p:txBody>
-      </p:sp>
-      <p:sp>
-        <p:nvSpPr>
-          <p:cNvPr id="20" name="TextBox 19"/>
-          <p:cNvSpPr txBox="1"/>
-          <p:nvPr/>
-        </p:nvSpPr>
-        <p:spPr>
-          <a:xfrm>
-            <a:off x="5194934" y="6437376"/>
-            <a:ext cx="1194435" cy="152146"/>
-          </a:xfrm>
-          <a:prstGeom prst="rect">
-            <a:avLst/>
-          </a:prstGeom>
-          <a:noFill/>
-        </p:spPr>
-        <p:txBody>
-          <a:bodyPr wrap="square" anchor="t" lIns="0" rIns="0" tIns="0" bIns="0">
-            <a:spAutoFit/>
-          </a:bodyPr>
-          <a:lstStyle/>
-          <a:p>
-            <a:pPr algn="l"/>
-            <a:r>
-              <a:rPr sz="700" b="1" i="0">
-                <a:solidFill>
-                  <a:srgbClr val="5B3FD6"/>
-                </a:solidFill>
-                <a:latin typeface="Calibri"/>
-              </a:rPr>
-              <a:t>Is the tier healthy?</a:t>
-            </a:r>
-          </a:p>
-        </p:txBody>
-      </p:sp>
-      <p:sp>
-        <p:nvSpPr>
-          <p:cNvPr id="21" name="Oval 20"/>
-          <p:cNvSpPr/>
-          <p:nvPr/>
-        </p:nvSpPr>
-        <p:spPr>
-          <a:xfrm>
-            <a:off x="6480809" y="6492240"/>
-            <a:ext cx="64008" cy="64008"/>
-          </a:xfrm>
-          <a:prstGeom prst="ellipse">
-            <a:avLst/>
-          </a:prstGeom>
-          <a:solidFill>
-            <a:srgbClr val="CFC9EE"/>
-          </a:solidFill>
-          <a:ln>
-            <a:noFill/>
-          </a:ln>
-          <a:effectLst/>
-        </p:spPr>
-        <p:style>
-          <a:lnRef idx="1">
-            <a:schemeClr val="accent1"/>
-          </a:lnRef>
-          <a:fillRef idx="3">
-            <a:schemeClr val="accent1"/>
-          </a:fillRef>
-          <a:effectRef idx="2">
-            <a:schemeClr val="accent1"/>
-          </a:effectRef>
-          <a:fontRef idx="minor">
-            <a:schemeClr val="lt1"/>
-          </a:fontRef>
-        </p:style>
-        <p:txBody>
-          <a:bodyPr rtlCol="0" anchor="ctr" wrap="square"/>
-          <a:lstStyle/>
-          <a:p>
-            <a:pPr algn="ctr"/>
-          </a:p>
-        </p:txBody>
-      </p:sp>
-      <p:sp>
-        <p:nvSpPr>
           <p:cNvPr id="22" name="TextBox 21"/>
-          <p:cNvSpPr txBox="1"/>
-          <p:nvPr/>
-        </p:nvSpPr>
-        <p:spPr>
-          <a:xfrm>
-            <a:off x="6590538" y="6437376"/>
-            <a:ext cx="1240440" cy="152146"/>
-          </a:xfrm>
-          <a:prstGeom prst="rect">
-            <a:avLst/>
-          </a:prstGeom>
-          <a:noFill/>
-        </p:spPr>
-        <p:txBody>
-          <a:bodyPr wrap="square" anchor="t" lIns="0" rIns="0" tIns="0" bIns="0">
-            <a:spAutoFit/>
-          </a:bodyPr>
-          <a:lstStyle/>
-          <a:p>
-            <a:pPr algn="l"/>
-            <a:r>
-              <a:rPr sz="700" b="0" i="0">
-                <a:solidFill>
-                  <a:srgbClr val="6B6690"/>
-                </a:solidFill>
-                <a:latin typeface="Calibri"/>
-              </a:rPr>
-              <a:t>Can you say it aloud?</a:t>
-            </a:r>
-          </a:p>
-        </p:txBody>
-      </p:sp>
-      <p:sp>
-        <p:nvSpPr>
-          <p:cNvPr id="23" name="Oval 22"/>
-          <p:cNvSpPr/>
-          <p:nvPr/>
-        </p:nvSpPr>
-        <p:spPr>
-          <a:xfrm>
-            <a:off x="7922418" y="6492240"/>
-            <a:ext cx="64008" cy="64008"/>
-          </a:xfrm>
-          <a:prstGeom prst="ellipse">
-            <a:avLst/>
-          </a:prstGeom>
-          <a:solidFill>
-            <a:srgbClr val="CFC9EE"/>
-          </a:solidFill>
-          <a:ln>
-            <a:noFill/>
-          </a:ln>
-          <a:effectLst/>
-        </p:spPr>
-        <p:style>
-          <a:lnRef idx="1">
-            <a:schemeClr val="accent1"/>
-          </a:lnRef>
-          <a:fillRef idx="3">
-            <a:schemeClr val="accent1"/>
-          </a:fillRef>
-          <a:effectRef idx="2">
-            <a:schemeClr val="accent1"/>
-          </a:effectRef>
-          <a:fontRef idx="minor">
-            <a:schemeClr val="lt1"/>
-          </a:fontRef>
-        </p:style>
-        <p:txBody>
-          <a:bodyPr rtlCol="0" anchor="ctr" wrap="square"/>
-          <a:lstStyle/>
-          <a:p>
-            <a:pPr algn="ctr"/>
-          </a:p>
-        </p:txBody>
-      </p:sp>
-      <p:sp>
-        <p:nvSpPr>
-          <p:cNvPr id="24" name="TextBox 23"/>
           <p:cNvSpPr txBox="1"/>
           <p:nvPr/>
         </p:nvSpPr>
@@ -32470,7 +32313,7 @@
       </p:sp>
       <p:sp>
         <p:nvSpPr>
-          <p:cNvPr id="25" name="TextBox 24"/>
+          <p:cNvPr id="23" name="TextBox 22"/>
           <p:cNvSpPr txBox="1"/>
           <p:nvPr/>
         </p:nvSpPr>
@@ -33380,7 +33223,7 @@
                 </a:solidFill>
                 <a:latin typeface="Georgia"/>
               </a:rPr>
-              <a:t>Answer the ladder and the tree first: six questions</a:t>
+              <a:t>Answer: the six every screen asks about a sales drop</a:t>
             </a:r>
           </a:p>
         </p:txBody>
@@ -36301,7 +36144,7 @@
         <p:spPr>
           <a:xfrm>
             <a:off x="530352" y="1956816"/>
-            <a:ext cx="45720" cy="2733039"/>
+            <a:ext cx="45720" cy="3017519"/>
           </a:xfrm>
           <a:prstGeom prst="roundRect">
             <a:avLst>
@@ -36347,7 +36190,7 @@
         <p:spPr>
           <a:xfrm>
             <a:off x="786384" y="1956816"/>
-            <a:ext cx="10820095" cy="2733039"/>
+            <a:ext cx="10820095" cy="3017519"/>
           </a:xfrm>
           <a:prstGeom prst="rect">
             <a:avLst/>
@@ -36367,7 +36210,7 @@
                 </a:solidFill>
                 <a:latin typeface="Georgia"/>
               </a:rPr>
-              <a:t>"Revenue fell 11.0 percent between two closed quarters, Rs 2.10 crore to Rs 1.87 crore on the export as it stands. Customers held at 69, every one of them buying in both quarters, so acquisition is not the branch that moved; orders per customer fell from 1.65 to 1.25. In behaviour the fall sits in Retail-Plus, where the same 22 members placed 26 orders against 51, and revenue per order rose mainly because those small orders disappeared. In rupees most of it is three fewer Business orders, each worth lakhs, so one account's timing moves it by lakhs. The fall began in July, before the reorder button broke, so the button explains at most about 4 orders; we are asking for the tier's July change log and the app's reorder logs."</a:t>
+              <a:t>"Revenue fell 11.0 percent between two closed quarters, Rs 2.10 crore to Rs 1.87 crore on the export as it stands. Customers held at 69, every one of them buying in both quarters, so acquisition is not the branch that moved; orders per customer fell from 1.65 to 1.25. In behaviour the fall sits in Retail-Plus, where the same 22 members placed 26 orders against 51, and revenue per order rose mainly because those small orders disappeared. In rupees most of it is three fewer Business orders, each worth lakhs, so one account's timing moves it by lakhs. The fall began in July, before the reorder button broke, so the button explains at most about 4 orders on the 55 days before the break, or 7.0 on the 37 days just before it; we are asking for the tier's July change log and the app's reorder logs."</a:t>
             </a:r>
           </a:p>
           <a:p>
@@ -40287,7 +40130,7 @@
                 </a:solidFill>
                 <a:latin typeface="Calibri"/>
               </a:rPr>
-              <a:t>Was it the season?</a:t>
+              <a:t>A season for everyone?</a:t>
             </a:r>
           </a:p>
         </p:txBody>
@@ -42909,67 +42752,56 @@
       </p:sp>
       <p:sp>
         <p:nvSpPr>
-          <p:cNvPr id="21" name="Rounded Rectangle 20"/>
+          <p:cNvPr id="21" name="TextBox 20"/>
+          <p:cNvSpPr txBox="1"/>
+          <p:nvPr/>
+        </p:nvSpPr>
+        <p:spPr>
+          <a:xfrm>
+            <a:off x="530352" y="3419856"/>
+            <a:ext cx="11130991" cy="772160"/>
+          </a:xfrm>
+          <a:prstGeom prst="rect">
+            <a:avLst/>
+          </a:prstGeom>
+          <a:noFill/>
+        </p:spPr>
+        <p:txBody>
+          <a:bodyPr wrap="square" anchor="t" lIns="0" rIns="0" tIns="0" bIns="0">
+            <a:spAutoFit/>
+          </a:bodyPr>
+          <a:lstStyle/>
+          <a:p>
+            <a:pPr>
+              <a:spcAft>
+                <a:spcPts val="800"/>
+              </a:spcAft>
+            </a:pPr>
+            <a:r>
+              <a:rPr sz="1600" b="0" i="0">
+                <a:solidFill>
+                  <a:srgbClr val="1A1440"/>
+                </a:solidFill>
+                <a:latin typeface="Calibri"/>
+              </a:rPr>
+              <a:t>A company can put a broken app into its numbers, and the head of Retail-Plus is asking whether his tier is the same story. Guidance is the revenue a company tells investors to expect.</a:t>
+            </a:r>
+          </a:p>
+        </p:txBody>
+      </p:sp>
+      <p:sp>
+        <p:nvSpPr>
+          <p:cNvPr id="22" name="Oval 21"/>
           <p:cNvSpPr/>
           <p:nvPr/>
         </p:nvSpPr>
         <p:spPr>
           <a:xfrm>
-            <a:off x="530352" y="3419856"/>
-            <a:ext cx="11130991" cy="807720"/>
-          </a:xfrm>
-          <a:prstGeom prst="roundRect">
-            <a:avLst>
-              <a:gd name="adj" fmla="val 8000"/>
-            </a:avLst>
-          </a:prstGeom>
-          <a:solidFill>
-            <a:srgbClr val="F7F5FD"/>
-          </a:solidFill>
-          <a:ln w="9525">
-            <a:solidFill>
-              <a:srgbClr val="E4E1F1"/>
-            </a:solidFill>
-          </a:ln>
-          <a:effectLst/>
-        </p:spPr>
-        <p:style>
-          <a:lnRef idx="1">
-            <a:schemeClr val="accent1"/>
-          </a:lnRef>
-          <a:fillRef idx="3">
-            <a:schemeClr val="accent1"/>
-          </a:fillRef>
-          <a:effectRef idx="2">
-            <a:schemeClr val="accent1"/>
-          </a:effectRef>
-          <a:fontRef idx="minor">
-            <a:schemeClr val="lt1"/>
-          </a:fontRef>
-        </p:style>
-        <p:txBody>
-          <a:bodyPr rtlCol="0" anchor="ctr" wrap="square"/>
-          <a:lstStyle/>
-          <a:p>
-            <a:pPr algn="ctr"/>
-          </a:p>
-        </p:txBody>
-      </p:sp>
-      <p:sp>
-        <p:nvSpPr>
-          <p:cNvPr id="22" name="Rounded Rectangle 21"/>
-          <p:cNvSpPr/>
-          <p:nvPr/>
-        </p:nvSpPr>
-        <p:spPr>
-          <a:xfrm>
-            <a:off x="676656" y="3547872"/>
-            <a:ext cx="45720" cy="551688"/>
-          </a:xfrm>
-          <a:prstGeom prst="roundRect">
-            <a:avLst>
-              <a:gd name="adj" fmla="val 50000"/>
-            </a:avLst>
+            <a:off x="530352" y="6492240"/>
+            <a:ext cx="64008" cy="64008"/>
+          </a:xfrm>
+          <a:prstGeom prst="ellipse">
+            <a:avLst/>
           </a:prstGeom>
           <a:solidFill>
             <a:srgbClr val="5B3FD6"/>
@@ -43009,93 +42841,6 @@
         </p:nvSpPr>
         <p:spPr>
           <a:xfrm>
-            <a:off x="877824" y="3538728"/>
-            <a:ext cx="10564063" cy="624840"/>
-          </a:xfrm>
-          <a:prstGeom prst="rect">
-            <a:avLst/>
-          </a:prstGeom>
-          <a:noFill/>
-        </p:spPr>
-        <p:txBody>
-          <a:bodyPr wrap="square" anchor="ctr" lIns="0" rIns="0" tIns="0" bIns="0">
-            <a:spAutoFit/>
-          </a:bodyPr>
-          <a:lstStyle/>
-          <a:p>
-            <a:r>
-              <a:rPr sz="1500" b="1">
-                <a:solidFill>
-                  <a:srgbClr val="5B3FD6"/>
-                </a:solidFill>
-                <a:latin typeface="Calibri"/>
-              </a:rPr>
-              <a:t>The claim. </a:t>
-            </a:r>
-            <a:r>
-              <a:rPr sz="1500" b="0" i="0">
-                <a:solidFill>
-                  <a:srgbClr val="1A1440"/>
-                </a:solidFill>
-                <a:latin typeface="Calibri"/>
-              </a:rPr>
-              <a:t>A company can put a broken app into its numbers, and the head of Retail-Plus is asking whether his tier is the same story. Guidance is the revenue a company tells investors to expect.</a:t>
-            </a:r>
-          </a:p>
-        </p:txBody>
-      </p:sp>
-      <p:sp>
-        <p:nvSpPr>
-          <p:cNvPr id="24" name="Oval 23"/>
-          <p:cNvSpPr/>
-          <p:nvPr/>
-        </p:nvSpPr>
-        <p:spPr>
-          <a:xfrm>
-            <a:off x="530352" y="6492240"/>
-            <a:ext cx="64008" cy="64008"/>
-          </a:xfrm>
-          <a:prstGeom prst="ellipse">
-            <a:avLst/>
-          </a:prstGeom>
-          <a:solidFill>
-            <a:srgbClr val="5B3FD6"/>
-          </a:solidFill>
-          <a:ln>
-            <a:noFill/>
-          </a:ln>
-          <a:effectLst/>
-        </p:spPr>
-        <p:style>
-          <a:lnRef idx="1">
-            <a:schemeClr val="accent1"/>
-          </a:lnRef>
-          <a:fillRef idx="3">
-            <a:schemeClr val="accent1"/>
-          </a:fillRef>
-          <a:effectRef idx="2">
-            <a:schemeClr val="accent1"/>
-          </a:effectRef>
-          <a:fontRef idx="minor">
-            <a:schemeClr val="lt1"/>
-          </a:fontRef>
-        </p:style>
-        <p:txBody>
-          <a:bodyPr rtlCol="0" anchor="ctr" wrap="square"/>
-          <a:lstStyle/>
-          <a:p>
-            <a:pPr algn="ctr"/>
-          </a:p>
-        </p:txBody>
-      </p:sp>
-      <p:sp>
-        <p:nvSpPr>
-          <p:cNvPr id="25" name="TextBox 24"/>
-          <p:cNvSpPr txBox="1"/>
-          <p:nvPr/>
-        </p:nvSpPr>
-        <p:spPr>
-          <a:xfrm>
             <a:off x="640080" y="6437376"/>
             <a:ext cx="1240440" cy="152146"/>
           </a:xfrm>
@@ -43125,7 +42870,7 @@
       </p:sp>
       <p:sp>
         <p:nvSpPr>
-          <p:cNvPr id="26" name="Oval 25"/>
+          <p:cNvPr id="24" name="Oval 23"/>
           <p:cNvSpPr/>
           <p:nvPr/>
         </p:nvSpPr>
@@ -43169,7 +42914,7 @@
       </p:sp>
       <p:sp>
         <p:nvSpPr>
-          <p:cNvPr id="27" name="TextBox 26"/>
+          <p:cNvPr id="25" name="TextBox 24"/>
           <p:cNvSpPr txBox="1"/>
           <p:nvPr/>
         </p:nvSpPr>
@@ -43204,7 +42949,7 @@
       </p:sp>
       <p:sp>
         <p:nvSpPr>
-          <p:cNvPr id="28" name="Oval 27"/>
+          <p:cNvPr id="26" name="Oval 25"/>
           <p:cNvSpPr/>
           <p:nvPr/>
         </p:nvSpPr>
@@ -43248,7 +42993,7 @@
       </p:sp>
       <p:sp>
         <p:nvSpPr>
-          <p:cNvPr id="29" name="TextBox 28"/>
+          <p:cNvPr id="27" name="TextBox 26"/>
           <p:cNvSpPr txBox="1"/>
           <p:nvPr/>
         </p:nvSpPr>
@@ -43283,7 +43028,7 @@
       </p:sp>
       <p:sp>
         <p:nvSpPr>
-          <p:cNvPr id="30" name="Oval 29"/>
+          <p:cNvPr id="28" name="Oval 27"/>
           <p:cNvSpPr/>
           <p:nvPr/>
         </p:nvSpPr>
@@ -43327,7 +43072,7 @@
       </p:sp>
       <p:sp>
         <p:nvSpPr>
-          <p:cNvPr id="31" name="TextBox 30"/>
+          <p:cNvPr id="29" name="TextBox 28"/>
           <p:cNvSpPr txBox="1"/>
           <p:nvPr/>
         </p:nvSpPr>
@@ -43362,7 +43107,7 @@
       </p:sp>
       <p:sp>
         <p:nvSpPr>
-          <p:cNvPr id="32" name="Oval 31"/>
+          <p:cNvPr id="30" name="Oval 29"/>
           <p:cNvSpPr/>
           <p:nvPr/>
         </p:nvSpPr>
@@ -43406,7 +43151,7 @@
       </p:sp>
       <p:sp>
         <p:nvSpPr>
-          <p:cNvPr id="33" name="TextBox 32"/>
+          <p:cNvPr id="31" name="TextBox 30"/>
           <p:cNvSpPr txBox="1"/>
           <p:nvPr/>
         </p:nvSpPr>
@@ -43441,7 +43186,7 @@
       </p:sp>
       <p:sp>
         <p:nvSpPr>
-          <p:cNvPr id="34" name="Oval 33"/>
+          <p:cNvPr id="32" name="Oval 31"/>
           <p:cNvSpPr/>
           <p:nvPr/>
         </p:nvSpPr>
@@ -43485,7 +43230,7 @@
       </p:sp>
       <p:sp>
         <p:nvSpPr>
-          <p:cNvPr id="35" name="TextBox 34"/>
+          <p:cNvPr id="33" name="TextBox 32"/>
           <p:cNvSpPr txBox="1"/>
           <p:nvPr/>
         </p:nvSpPr>
@@ -43520,7 +43265,7 @@
       </p:sp>
       <p:sp>
         <p:nvSpPr>
-          <p:cNvPr id="36" name="TextBox 35"/>
+          <p:cNvPr id="34" name="TextBox 33"/>
           <p:cNvSpPr txBox="1"/>
           <p:nvPr/>
         </p:nvSpPr>
@@ -45099,7 +44844,7 @@
         <p:spPr>
           <a:xfrm>
             <a:off x="5761917" y="1956816"/>
-            <a:ext cx="5899425" cy="1639824"/>
+            <a:ext cx="5899425" cy="1380744"/>
           </a:xfrm>
           <a:prstGeom prst="roundRect">
             <a:avLst>
@@ -45152,7 +44897,7 @@
         </p:nvSpPr>
         <p:spPr>
           <a:xfrm>
-            <a:off x="5990517" y="2548128"/>
+            <a:off x="5990517" y="2418588"/>
             <a:ext cx="457200" cy="457200"/>
           </a:xfrm>
           <a:prstGeom prst="ellipse">
@@ -45204,7 +44949,7 @@
         </p:blipFill>
         <p:spPr>
           <a:xfrm>
-            <a:off x="6100245" y="2657856"/>
+            <a:off x="6100245" y="2528316"/>
             <a:ext cx="237744" cy="237744"/>
           </a:xfrm>
           <a:prstGeom prst="rect">
@@ -45256,7 +45001,7 @@
         <p:spPr>
           <a:xfrm>
             <a:off x="6630597" y="2322576"/>
-            <a:ext cx="4756425" cy="1200912"/>
+            <a:ext cx="4756425" cy="941832"/>
           </a:xfrm>
           <a:prstGeom prst="rect">
             <a:avLst/>
@@ -45276,7 +45021,7 @@
                 </a:solidFill>
                 <a:latin typeface="Calibri"/>
               </a:rPr>
-              <a:t>Restate the cause as a mechanism and test each thing it predicts, timing first. A test the data can pass or fail is worth more than an opinion about the cause.</a:t>
+              <a:t>Restate the cause as a mechanism and test each thing it predicts, timing first, since a cause cannot come after its effect.</a:t>
             </a:r>
           </a:p>
         </p:txBody>
@@ -46039,8 +45784,8 @@
         </p:nvSpPr>
         <p:spPr>
           <a:xfrm>
-            <a:off x="530352" y="1806956"/>
-            <a:ext cx="11130991" cy="2981960"/>
+            <a:off x="530352" y="1913636"/>
+            <a:ext cx="11130991" cy="2837687"/>
           </a:xfrm>
           <a:prstGeom prst="roundRect">
             <a:avLst>
@@ -46091,7 +45836,7 @@
         </p:nvSpPr>
         <p:spPr>
           <a:xfrm>
-            <a:off x="713232" y="1934972"/>
+            <a:off x="713232" y="2041652"/>
             <a:ext cx="91440" cy="91440"/>
           </a:xfrm>
           <a:prstGeom prst="ellipse">
@@ -46135,7 +45880,7 @@
         </p:nvSpPr>
         <p:spPr>
           <a:xfrm>
-            <a:off x="868680" y="1934972"/>
+            <a:off x="868680" y="2041652"/>
             <a:ext cx="91440" cy="91440"/>
           </a:xfrm>
           <a:prstGeom prst="ellipse">
@@ -46179,7 +45924,7 @@
         </p:nvSpPr>
         <p:spPr>
           <a:xfrm>
-            <a:off x="1024128" y="1934972"/>
+            <a:off x="1024128" y="2041652"/>
             <a:ext cx="91440" cy="91440"/>
           </a:xfrm>
           <a:prstGeom prst="ellipse">
@@ -46223,8 +45968,8 @@
         </p:nvSpPr>
         <p:spPr>
           <a:xfrm>
-            <a:off x="804671" y="2136140"/>
-            <a:ext cx="10673791" cy="2579624"/>
+            <a:off x="804671" y="2242820"/>
+            <a:ext cx="10673791" cy="2435352"/>
           </a:xfrm>
           <a:prstGeom prst="rect">
             <a:avLst/>
@@ -46243,13 +45988,13 @@
               </a:spcAft>
             </a:pPr>
             <a:r>
-              <a:rPr sz="1400" b="0" i="0">
-                <a:solidFill>
-                  <a:srgbClr val="E4E1F1"/>
+              <a:rPr sz="1200" b="0" i="0">
+                <a:solidFill>
+                  <a:srgbClr val="A9A3D2"/>
                 </a:solidFill>
                 <a:latin typeface="Consolas"/>
               </a:rPr>
-              <a:t>def count_by(rows, key):</a:t>
+              <a:t># plus: every Retail-Plus order in both quarters</a:t>
             </a:r>
           </a:p>
           <a:p>
@@ -46259,13 +46004,13 @@
               </a:spcAft>
             </a:pPr>
             <a:r>
-              <a:rPr sz="1400" b="0" i="0">
+              <a:rPr sz="1200" b="0" i="0">
                 <a:solidFill>
                   <a:srgbClr val="E4E1F1"/>
                 </a:solidFill>
                 <a:latin typeface="Consolas"/>
               </a:rPr>
-              <a:t>    """Count the rows under whatever key(row) returns."""</a:t>
+              <a:t>def count_by(rows, key):</a:t>
             </a:r>
           </a:p>
           <a:p>
@@ -46275,13 +46020,13 @@
               </a:spcAft>
             </a:pPr>
             <a:r>
-              <a:rPr sz="1400" b="0" i="0">
+              <a:rPr sz="1200" b="0" i="0">
                 <a:solidFill>
                   <a:srgbClr val="E4E1F1"/>
                 </a:solidFill>
                 <a:latin typeface="Consolas"/>
               </a:rPr>
-              <a:t>    counts = {}</a:t>
+              <a:t>    """Count the rows under whatever key(row) returns."""</a:t>
             </a:r>
           </a:p>
           <a:p>
@@ -46291,13 +46036,13 @@
               </a:spcAft>
             </a:pPr>
             <a:r>
-              <a:rPr sz="1400" b="0" i="0">
+              <a:rPr sz="1200" b="0" i="0">
                 <a:solidFill>
                   <a:srgbClr val="E4E1F1"/>
                 </a:solidFill>
                 <a:latin typeface="Consolas"/>
               </a:rPr>
-              <a:t>    for row in rows:</a:t>
+              <a:t>    counts = {}</a:t>
             </a:r>
           </a:p>
           <a:p>
@@ -46307,13 +46052,13 @@
               </a:spcAft>
             </a:pPr>
             <a:r>
-              <a:rPr sz="1400" b="0" i="0">
+              <a:rPr sz="1200" b="0" i="0">
                 <a:solidFill>
                   <a:srgbClr val="E4E1F1"/>
                 </a:solidFill>
                 <a:latin typeface="Consolas"/>
               </a:rPr>
-              <a:t>        k = key(row)</a:t>
+              <a:t>    for row in rows:</a:t>
             </a:r>
           </a:p>
           <a:p>
@@ -46323,13 +46068,13 @@
               </a:spcAft>
             </a:pPr>
             <a:r>
-              <a:rPr sz="1400" b="0" i="0">
+              <a:rPr sz="1200" b="0" i="0">
                 <a:solidFill>
                   <a:srgbClr val="E4E1F1"/>
                 </a:solidFill>
                 <a:latin typeface="Consolas"/>
               </a:rPr>
-              <a:t>        counts[k] = counts.get(k, 0) + 1</a:t>
+              <a:t>        k = key(row)</a:t>
             </a:r>
           </a:p>
           <a:p>
@@ -46339,13 +46084,13 @@
               </a:spcAft>
             </a:pPr>
             <a:r>
-              <a:rPr sz="1400" b="0" i="0">
+              <a:rPr sz="1200" b="0" i="0">
                 <a:solidFill>
                   <a:srgbClr val="E4E1F1"/>
                 </a:solidFill>
                 <a:latin typeface="Consolas"/>
               </a:rPr>
-              <a:t>    return counts</a:t>
+              <a:t>        counts[k] = counts.get(k, 0) + 1</a:t>
             </a:r>
           </a:p>
           <a:p>
@@ -46354,6 +46099,15 @@
                 <a:spcPts val="200"/>
               </a:spcAft>
             </a:pPr>
+            <a:r>
+              <a:rPr sz="1200" b="0" i="0">
+                <a:solidFill>
+                  <a:srgbClr val="E4E1F1"/>
+                </a:solidFill>
+                <a:latin typeface="Consolas"/>
+              </a:rPr>
+              <a:t>    return counts</a:t>
+            </a:r>
           </a:p>
           <a:p>
             <a:pPr>
@@ -46361,15 +46115,6 @@
                 <a:spcPts val="200"/>
               </a:spcAft>
             </a:pPr>
-            <a:r>
-              <a:rPr sz="1400" b="0" i="0">
-                <a:solidFill>
-                  <a:srgbClr val="E4E1F1"/>
-                </a:solidFill>
-                <a:latin typeface="Consolas"/>
-              </a:rPr>
-              <a:t>plus_month = count_by(plus, lambda o: o["order_date"][:7])     # "2026-07"</a:t>
-            </a:r>
           </a:p>
           <a:p>
             <a:pPr>
@@ -46378,7 +46123,23 @@
               </a:spcAft>
             </a:pPr>
             <a:r>
-              <a:rPr sz="1400" b="0" i="0">
+              <a:rPr sz="1200" b="0" i="0">
+                <a:solidFill>
+                  <a:srgbClr val="E4E1F1"/>
+                </a:solidFill>
+                <a:latin typeface="Consolas"/>
+              </a:rPr>
+              <a:t>plus_month = count_by(plus, lambda o: o["order_date"][:7])     # "2026-07"</a:t>
+            </a:r>
+          </a:p>
+          <a:p>
+            <a:pPr>
+              <a:spcAft>
+                <a:spcPts val="200"/>
+              </a:spcAft>
+            </a:pPr>
+            <a:r>
+              <a:rPr sz="1200" b="0" i="0">
                 <a:solidFill>
                   <a:srgbClr val="E4E1F1"/>
                 </a:solidFill>
@@ -46397,8 +46158,8 @@
         </p:nvSpPr>
         <p:spPr>
           <a:xfrm>
-            <a:off x="530352" y="4953508"/>
-            <a:ext cx="11130991" cy="1121664"/>
+            <a:off x="530352" y="4915916"/>
+            <a:ext cx="11130991" cy="1052576"/>
           </a:xfrm>
           <a:prstGeom prst="roundRect">
             <a:avLst>
@@ -46451,7 +46212,7 @@
         </p:nvSpPr>
         <p:spPr>
           <a:xfrm>
-            <a:off x="758952" y="5285739"/>
+            <a:off x="758952" y="5213604"/>
             <a:ext cx="457200" cy="457200"/>
           </a:xfrm>
           <a:prstGeom prst="ellipse">
@@ -46503,7 +46264,7 @@
         </p:blipFill>
         <p:spPr>
           <a:xfrm>
-            <a:off x="868680" y="5395468"/>
+            <a:off x="868680" y="5323332"/>
             <a:ext cx="237744" cy="237744"/>
           </a:xfrm>
           <a:prstGeom prst="rect">
@@ -46519,7 +46280,7 @@
         </p:nvSpPr>
         <p:spPr>
           <a:xfrm>
-            <a:off x="1399031" y="5099812"/>
+            <a:off x="1399031" y="5062220"/>
             <a:ext cx="9987991" cy="160401"/>
           </a:xfrm>
           <a:prstGeom prst="rect">
@@ -46554,22 +46315,22 @@
         </p:nvSpPr>
         <p:spPr>
           <a:xfrm>
-            <a:off x="1399031" y="5319268"/>
-            <a:ext cx="9987991" cy="682752"/>
-          </a:xfrm>
-          <a:prstGeom prst="rect">
-            <a:avLst/>
-          </a:prstGeom>
-          <a:noFill/>
-        </p:spPr>
-        <p:txBody>
-          <a:bodyPr wrap="square" anchor="t" lIns="0" rIns="0" tIns="0" bIns="0">
-            <a:spAutoFit/>
-          </a:bodyPr>
-          <a:lstStyle/>
-          <a:p>
-            <a:r>
-              <a:rPr sz="1500" b="0" i="0">
+            <a:off x="1399031" y="5281676"/>
+            <a:ext cx="9987991" cy="613664"/>
+          </a:xfrm>
+          <a:prstGeom prst="rect">
+            <a:avLst/>
+          </a:prstGeom>
+          <a:noFill/>
+        </p:spPr>
+        <p:txBody>
+          <a:bodyPr wrap="square" anchor="t" lIns="0" rIns="0" tIns="0" bIns="0">
+            <a:spAutoFit/>
+          </a:bodyPr>
+          <a:lstStyle/>
+          <a:p>
+            <a:r>
+              <a:rPr sz="1300" b="0" i="0">
                 <a:solidFill>
                   <a:srgbClr val="1A1440"/>
                 </a:solidFill>

</xml_diff>